<commit_message>
[EJIT] Add progress roadmap slide
Co-Authored-By: Claude Opus 4.8 <noreply@anthropic.com>
</commit_message>
<xml_diff>
--- a/jit_design_doc/EJIT进展_20260627.pptx
+++ b/jit_design_doc/EJIT进展_20260627.pptx
@@ -8,6 +8,7 @@
     <p:sldId id="256" r:id="rId7"/>
     <p:sldId id="257" r:id="rId8"/>
     <p:sldId id="258" r:id="rId9"/>
+    <p:sldId id="259" r:id="rId10"/>
   </p:sldIdLst>
   <p:sldSz cx="12191695" cy="6858000" type="screen4x3"/>
   <p:notesSz cx="6858000" cy="9144000"/>
@@ -5488,7 +5489,7 @@
                 </a:solidFill>
                 <a:latin typeface="微软雅黑"/>
               </a:rPr>
-              <a:t>39.8K</a:t>
+              <a:t>40.3K</a:t>
             </a:r>
           </a:p>
         </p:txBody>
@@ -5604,7 +5605,7 @@
                 </a:solidFill>
                 <a:latin typeface="微软雅黑"/>
               </a:rPr>
-              <a:t>28.3K</a:t>
+              <a:t>28.9K</a:t>
             </a:r>
           </a:p>
         </p:txBody>
@@ -5836,7 +5837,7 @@
                 </a:solidFill>
                 <a:latin typeface="微软雅黑"/>
               </a:rPr>
-              <a:t>236</a:t>
+              <a:t>238</a:t>
             </a:r>
           </a:p>
         </p:txBody>
@@ -19852,6 +19853,4184 @@
 </file>
 
 <file path=ppt/slides/slide3.xml><?xml version="1.0" encoding="utf-8"?>
+<p:sld xmlns:a="http://schemas.openxmlformats.org/drawingml/2006/main" xmlns:p="http://schemas.openxmlformats.org/presentationml/2006/main" xmlns:r="http://schemas.openxmlformats.org/officeDocument/2006/relationships">
+  <p:cSld>
+    <p:spTree>
+      <p:nvGrpSpPr>
+        <p:cNvPr id="1" name=""/>
+        <p:cNvGrpSpPr/>
+        <p:nvPr/>
+      </p:nvGrpSpPr>
+      <p:grpSpPr/>
+      <p:sp>
+        <p:nvSpPr>
+          <p:cNvPr id="2" name="Rectangle 1"/>
+          <p:cNvSpPr/>
+          <p:nvPr/>
+        </p:nvSpPr>
+        <p:spPr>
+          <a:xfrm>
+            <a:off x="0" y="0"/>
+            <a:ext cx="12191695" cy="64008"/>
+          </a:xfrm>
+          <a:prstGeom prst="rect">
+            <a:avLst/>
+          </a:prstGeom>
+          <a:solidFill>
+            <a:srgbClr val="2C5282"/>
+          </a:solidFill>
+          <a:ln>
+            <a:noFill/>
+          </a:ln>
+          <a:effectLst/>
+        </p:spPr>
+        <p:style>
+          <a:lnRef idx="1">
+            <a:schemeClr val="accent1"/>
+          </a:lnRef>
+          <a:fillRef idx="3">
+            <a:schemeClr val="accent1"/>
+          </a:fillRef>
+          <a:effectRef idx="2">
+            <a:schemeClr val="accent1"/>
+          </a:effectRef>
+          <a:fontRef idx="minor">
+            <a:schemeClr val="lt1"/>
+          </a:fontRef>
+        </p:style>
+        <p:txBody>
+          <a:bodyPr rtlCol="0" anchor="ctr"/>
+          <a:lstStyle/>
+          <a:p>
+            <a:pPr algn="ctr"/>
+          </a:p>
+        </p:txBody>
+      </p:sp>
+      <p:sp>
+        <p:nvSpPr>
+          <p:cNvPr id="3" name="Rectangle 2"/>
+          <p:cNvSpPr/>
+          <p:nvPr/>
+        </p:nvSpPr>
+        <p:spPr>
+          <a:xfrm>
+            <a:off x="0" y="64008"/>
+            <a:ext cx="411480" cy="502920"/>
+          </a:xfrm>
+          <a:prstGeom prst="rect">
+            <a:avLst/>
+          </a:prstGeom>
+          <a:solidFill>
+            <a:srgbClr val="2C5282"/>
+          </a:solidFill>
+          <a:ln>
+            <a:noFill/>
+          </a:ln>
+          <a:effectLst/>
+        </p:spPr>
+        <p:style>
+          <a:lnRef idx="1">
+            <a:schemeClr val="accent1"/>
+          </a:lnRef>
+          <a:fillRef idx="3">
+            <a:schemeClr val="accent1"/>
+          </a:fillRef>
+          <a:effectRef idx="2">
+            <a:schemeClr val="accent1"/>
+          </a:effectRef>
+          <a:fontRef idx="minor">
+            <a:schemeClr val="lt1"/>
+          </a:fontRef>
+        </p:style>
+        <p:txBody>
+          <a:bodyPr rtlCol="0" anchor="ctr"/>
+          <a:lstStyle/>
+          <a:p>
+            <a:pPr algn="ctr"/>
+          </a:p>
+        </p:txBody>
+      </p:sp>
+      <p:sp>
+        <p:nvSpPr>
+          <p:cNvPr id="4" name="TextBox 3"/>
+          <p:cNvSpPr txBox="1"/>
+          <p:nvPr/>
+        </p:nvSpPr>
+        <p:spPr>
+          <a:xfrm>
+            <a:off x="548640" y="109728"/>
+            <a:ext cx="10058400" cy="457200"/>
+          </a:xfrm>
+          <a:prstGeom prst="rect">
+            <a:avLst/>
+          </a:prstGeom>
+          <a:noFill/>
+        </p:spPr>
+        <p:txBody>
+          <a:bodyPr wrap="square" anchor="ctr">
+            <a:spAutoFit/>
+          </a:bodyPr>
+          <a:lstStyle/>
+          <a:p>
+            <a:pPr algn="l"/>
+            <a:r>
+              <a:rPr sz="2300" b="1">
+                <a:solidFill>
+                  <a:srgbClr val="2D3748"/>
+                </a:solidFill>
+                <a:latin typeface="微软雅黑"/>
+              </a:rPr>
+              <a:t>EJIT 后续工作规划</a:t>
+            </a:r>
+          </a:p>
+        </p:txBody>
+      </p:sp>
+      <p:sp>
+        <p:nvSpPr>
+          <p:cNvPr id="5" name="TextBox 4"/>
+          <p:cNvSpPr txBox="1"/>
+          <p:nvPr/>
+        </p:nvSpPr>
+        <p:spPr>
+          <a:xfrm>
+            <a:off x="548640" y="530352"/>
+            <a:ext cx="11338560" cy="237744"/>
+          </a:xfrm>
+          <a:prstGeom prst="rect">
+            <a:avLst/>
+          </a:prstGeom>
+          <a:noFill/>
+        </p:spPr>
+        <p:txBody>
+          <a:bodyPr wrap="square" anchor="t">
+            <a:spAutoFit/>
+          </a:bodyPr>
+          <a:lstStyle/>
+          <a:p>
+            <a:pPr algn="l"/>
+            <a:r>
+              <a:rPr sz="1050" b="0">
+                <a:solidFill>
+                  <a:srgbClr val="595959"/>
+                </a:solidFill>
+                <a:latin typeface="微软雅黑"/>
+              </a:rPr>
+              <a:t>从代码完成 → 真机验证 → 性能收益 → 可交付工程化</a:t>
+            </a:r>
+          </a:p>
+        </p:txBody>
+      </p:sp>
+      <p:sp>
+        <p:nvSpPr>
+          <p:cNvPr id="6" name="Rectangle 5"/>
+          <p:cNvSpPr/>
+          <p:nvPr/>
+        </p:nvSpPr>
+        <p:spPr>
+          <a:xfrm>
+            <a:off x="0" y="804672"/>
+            <a:ext cx="12191695" cy="13716"/>
+          </a:xfrm>
+          <a:prstGeom prst="rect">
+            <a:avLst/>
+          </a:prstGeom>
+          <a:solidFill>
+            <a:srgbClr val="D9DEE6"/>
+          </a:solidFill>
+          <a:ln>
+            <a:noFill/>
+          </a:ln>
+          <a:effectLst/>
+        </p:spPr>
+        <p:style>
+          <a:lnRef idx="1">
+            <a:schemeClr val="accent1"/>
+          </a:lnRef>
+          <a:fillRef idx="3">
+            <a:schemeClr val="accent1"/>
+          </a:fillRef>
+          <a:effectRef idx="2">
+            <a:schemeClr val="accent1"/>
+          </a:effectRef>
+          <a:fontRef idx="minor">
+            <a:schemeClr val="lt1"/>
+          </a:fontRef>
+        </p:style>
+        <p:txBody>
+          <a:bodyPr rtlCol="0" anchor="ctr"/>
+          <a:lstStyle/>
+          <a:p>
+            <a:pPr algn="ctr"/>
+          </a:p>
+        </p:txBody>
+      </p:sp>
+      <p:sp>
+        <p:nvSpPr>
+          <p:cNvPr id="7" name="Rectangle 6"/>
+          <p:cNvSpPr/>
+          <p:nvPr/>
+        </p:nvSpPr>
+        <p:spPr>
+          <a:xfrm>
+            <a:off x="320040" y="896112"/>
+            <a:ext cx="11567160" cy="457200"/>
+          </a:xfrm>
+          <a:prstGeom prst="rect">
+            <a:avLst/>
+          </a:prstGeom>
+          <a:solidFill>
+            <a:srgbClr val="2C5282"/>
+          </a:solidFill>
+          <a:ln>
+            <a:noFill/>
+          </a:ln>
+          <a:effectLst/>
+        </p:spPr>
+        <p:style>
+          <a:lnRef idx="1">
+            <a:schemeClr val="accent1"/>
+          </a:lnRef>
+          <a:fillRef idx="3">
+            <a:schemeClr val="accent1"/>
+          </a:fillRef>
+          <a:effectRef idx="2">
+            <a:schemeClr val="accent1"/>
+          </a:effectRef>
+          <a:fontRef idx="minor">
+            <a:schemeClr val="lt1"/>
+          </a:fontRef>
+        </p:style>
+        <p:txBody>
+          <a:bodyPr rtlCol="0" anchor="ctr"/>
+          <a:lstStyle/>
+          <a:p>
+            <a:pPr algn="ctr"/>
+          </a:p>
+        </p:txBody>
+      </p:sp>
+      <p:sp>
+        <p:nvSpPr>
+          <p:cNvPr id="8" name="TextBox 7"/>
+          <p:cNvSpPr txBox="1"/>
+          <p:nvPr/>
+        </p:nvSpPr>
+        <p:spPr>
+          <a:xfrm>
+            <a:off x="320040" y="896112"/>
+            <a:ext cx="11567160" cy="457200"/>
+          </a:xfrm>
+          <a:prstGeom prst="rect">
+            <a:avLst/>
+          </a:prstGeom>
+          <a:noFill/>
+        </p:spPr>
+        <p:txBody>
+          <a:bodyPr wrap="square" anchor="ctr">
+            <a:spAutoFit/>
+          </a:bodyPr>
+          <a:lstStyle/>
+          <a:p>
+            <a:pPr algn="ctr"/>
+            <a:r>
+              <a:rPr sz="1150" b="1">
+                <a:solidFill>
+                  <a:srgbClr val="FFFFFF"/>
+                </a:solidFill>
+                <a:latin typeface="微软雅黑"/>
+              </a:rPr>
+              <a:t>目标: 形成可复现的 EJIT 闭环证据链 —— </a:t>
+            </a:r>
+            <a:r>
+              <a:rPr sz="1150" b="1">
+                <a:solidFill>
+                  <a:srgbClr val="CFE0F5"/>
+                </a:solidFill>
+                <a:latin typeface="微软雅黑"/>
+              </a:rPr>
+              <a:t>真机可跑</a:t>
+            </a:r>
+            <a:r>
+              <a:rPr sz="1150" b="1">
+                <a:solidFill>
+                  <a:srgbClr val="FFFFFF"/>
+                </a:solidFill>
+                <a:latin typeface="微软雅黑"/>
+              </a:rPr>
+              <a:t> / </a:t>
+            </a:r>
+            <a:r>
+              <a:rPr sz="1150" b="1">
+                <a:solidFill>
+                  <a:srgbClr val="CFE0F5"/>
+                </a:solidFill>
+                <a:latin typeface="微软雅黑"/>
+              </a:rPr>
+              <a:t>收益可量化</a:t>
+            </a:r>
+            <a:r>
+              <a:rPr sz="1150" b="1">
+                <a:solidFill>
+                  <a:srgbClr val="FFFFFF"/>
+                </a:solidFill>
+                <a:latin typeface="微软雅黑"/>
+              </a:rPr>
+              <a:t> / </a:t>
+            </a:r>
+            <a:r>
+              <a:rPr sz="1150" b="1">
+                <a:solidFill>
+                  <a:srgbClr val="CFE0F5"/>
+                </a:solidFill>
+                <a:latin typeface="微软雅黑"/>
+              </a:rPr>
+              <a:t>交付可裁剪</a:t>
+            </a:r>
+          </a:p>
+        </p:txBody>
+      </p:sp>
+      <p:sp>
+        <p:nvSpPr>
+          <p:cNvPr id="9" name="Rectangle 8"/>
+          <p:cNvSpPr/>
+          <p:nvPr/>
+        </p:nvSpPr>
+        <p:spPr>
+          <a:xfrm>
+            <a:off x="320040" y="1508760"/>
+            <a:ext cx="3733800" cy="384048"/>
+          </a:xfrm>
+          <a:prstGeom prst="rect">
+            <a:avLst/>
+          </a:prstGeom>
+          <a:solidFill>
+            <a:srgbClr val="38A16F"/>
+          </a:solidFill>
+          <a:ln>
+            <a:noFill/>
+          </a:ln>
+          <a:effectLst/>
+        </p:spPr>
+        <p:style>
+          <a:lnRef idx="1">
+            <a:schemeClr val="accent1"/>
+          </a:lnRef>
+          <a:fillRef idx="3">
+            <a:schemeClr val="accent1"/>
+          </a:fillRef>
+          <a:effectRef idx="2">
+            <a:schemeClr val="accent1"/>
+          </a:effectRef>
+          <a:fontRef idx="minor">
+            <a:schemeClr val="lt1"/>
+          </a:fontRef>
+        </p:style>
+        <p:txBody>
+          <a:bodyPr rtlCol="0" anchor="ctr"/>
+          <a:lstStyle/>
+          <a:p>
+            <a:pPr algn="ctr"/>
+          </a:p>
+        </p:txBody>
+      </p:sp>
+      <p:sp>
+        <p:nvSpPr>
+          <p:cNvPr id="10" name="TextBox 9"/>
+          <p:cNvSpPr txBox="1"/>
+          <p:nvPr/>
+        </p:nvSpPr>
+        <p:spPr>
+          <a:xfrm>
+            <a:off x="429768" y="1508760"/>
+            <a:ext cx="3514344" cy="384048"/>
+          </a:xfrm>
+          <a:prstGeom prst="rect">
+            <a:avLst/>
+          </a:prstGeom>
+          <a:noFill/>
+        </p:spPr>
+        <p:txBody>
+          <a:bodyPr wrap="square" anchor="ctr">
+            <a:spAutoFit/>
+          </a:bodyPr>
+          <a:lstStyle/>
+          <a:p>
+            <a:pPr algn="l"/>
+            <a:r>
+              <a:rPr sz="1200" b="1">
+                <a:solidFill>
+                  <a:srgbClr val="FFFFFF"/>
+                </a:solidFill>
+                <a:latin typeface="微软雅黑"/>
+              </a:rPr>
+              <a:t>近期：验证闭环</a:t>
+            </a:r>
+            <a:r>
+              <a:rPr sz="1000" b="0">
+                <a:solidFill>
+                  <a:srgbClr val="FFFFFF"/>
+                </a:solidFill>
+                <a:latin typeface="微软雅黑"/>
+              </a:rPr>
+              <a:t>  ·  </a:t>
+            </a:r>
+            <a:r>
+              <a:rPr sz="1000" b="1">
+                <a:solidFill>
+                  <a:srgbClr val="E8F2FF"/>
+                </a:solidFill>
+                <a:latin typeface="微软雅黑"/>
+              </a:rPr>
+              <a:t>2~4 周</a:t>
+            </a:r>
+          </a:p>
+        </p:txBody>
+      </p:sp>
+      <p:sp>
+        <p:nvSpPr>
+          <p:cNvPr id="11" name="Rectangle 10"/>
+          <p:cNvSpPr/>
+          <p:nvPr/>
+        </p:nvSpPr>
+        <p:spPr>
+          <a:xfrm>
+            <a:off x="320040" y="2011680"/>
+            <a:ext cx="3733800" cy="658368"/>
+          </a:xfrm>
+          <a:prstGeom prst="rect">
+            <a:avLst/>
+          </a:prstGeom>
+          <a:solidFill>
+            <a:srgbClr val="FFFFFF"/>
+          </a:solidFill>
+          <a:ln w="9525">
+            <a:solidFill>
+              <a:srgbClr val="D9DEE6"/>
+            </a:solidFill>
+          </a:ln>
+          <a:effectLst/>
+        </p:spPr>
+        <p:style>
+          <a:lnRef idx="1">
+            <a:schemeClr val="accent1"/>
+          </a:lnRef>
+          <a:fillRef idx="3">
+            <a:schemeClr val="accent1"/>
+          </a:fillRef>
+          <a:effectRef idx="2">
+            <a:schemeClr val="accent1"/>
+          </a:effectRef>
+          <a:fontRef idx="minor">
+            <a:schemeClr val="lt1"/>
+          </a:fontRef>
+        </p:style>
+        <p:txBody>
+          <a:bodyPr rtlCol="0" anchor="ctr"/>
+          <a:lstStyle/>
+          <a:p>
+            <a:pPr algn="ctr"/>
+          </a:p>
+        </p:txBody>
+      </p:sp>
+      <p:sp>
+        <p:nvSpPr>
+          <p:cNvPr id="12" name="Rectangle 11"/>
+          <p:cNvSpPr/>
+          <p:nvPr/>
+        </p:nvSpPr>
+        <p:spPr>
+          <a:xfrm>
+            <a:off x="320040" y="2011680"/>
+            <a:ext cx="64008" cy="658368"/>
+          </a:xfrm>
+          <a:prstGeom prst="rect">
+            <a:avLst/>
+          </a:prstGeom>
+          <a:solidFill>
+            <a:srgbClr val="38A16F"/>
+          </a:solidFill>
+          <a:ln>
+            <a:noFill/>
+          </a:ln>
+          <a:effectLst/>
+        </p:spPr>
+        <p:style>
+          <a:lnRef idx="1">
+            <a:schemeClr val="accent1"/>
+          </a:lnRef>
+          <a:fillRef idx="3">
+            <a:schemeClr val="accent1"/>
+          </a:fillRef>
+          <a:effectRef idx="2">
+            <a:schemeClr val="accent1"/>
+          </a:effectRef>
+          <a:fontRef idx="minor">
+            <a:schemeClr val="lt1"/>
+          </a:fontRef>
+        </p:style>
+        <p:txBody>
+          <a:bodyPr rtlCol="0" anchor="ctr"/>
+          <a:lstStyle/>
+          <a:p>
+            <a:pPr algn="ctr"/>
+          </a:p>
+        </p:txBody>
+      </p:sp>
+      <p:sp>
+        <p:nvSpPr>
+          <p:cNvPr id="13" name="Rectangle 12"/>
+          <p:cNvSpPr/>
+          <p:nvPr/>
+        </p:nvSpPr>
+        <p:spPr>
+          <a:xfrm>
+            <a:off x="466344" y="2139696"/>
+            <a:ext cx="310896" cy="310896"/>
+          </a:xfrm>
+          <a:prstGeom prst="rect">
+            <a:avLst/>
+          </a:prstGeom>
+          <a:solidFill>
+            <a:srgbClr val="38A16F"/>
+          </a:solidFill>
+          <a:ln>
+            <a:noFill/>
+          </a:ln>
+          <a:effectLst/>
+        </p:spPr>
+        <p:style>
+          <a:lnRef idx="1">
+            <a:schemeClr val="accent1"/>
+          </a:lnRef>
+          <a:fillRef idx="3">
+            <a:schemeClr val="accent1"/>
+          </a:fillRef>
+          <a:effectRef idx="2">
+            <a:schemeClr val="accent1"/>
+          </a:effectRef>
+          <a:fontRef idx="minor">
+            <a:schemeClr val="lt1"/>
+          </a:fontRef>
+        </p:style>
+        <p:txBody>
+          <a:bodyPr rtlCol="0" anchor="ctr"/>
+          <a:lstStyle/>
+          <a:p>
+            <a:pPr algn="ctr"/>
+          </a:p>
+        </p:txBody>
+      </p:sp>
+      <p:sp>
+        <p:nvSpPr>
+          <p:cNvPr id="14" name="TextBox 13"/>
+          <p:cNvSpPr txBox="1"/>
+          <p:nvPr/>
+        </p:nvSpPr>
+        <p:spPr>
+          <a:xfrm>
+            <a:off x="466344" y="2139696"/>
+            <a:ext cx="310896" cy="310896"/>
+          </a:xfrm>
+          <a:prstGeom prst="rect">
+            <a:avLst/>
+          </a:prstGeom>
+          <a:noFill/>
+        </p:spPr>
+        <p:txBody>
+          <a:bodyPr wrap="square" anchor="ctr">
+            <a:spAutoFit/>
+          </a:bodyPr>
+          <a:lstStyle/>
+          <a:p>
+            <a:pPr algn="ctr"/>
+            <a:r>
+              <a:rPr sz="950" b="1">
+                <a:solidFill>
+                  <a:srgbClr val="FFFFFF"/>
+                </a:solidFill>
+                <a:latin typeface="微软雅黑"/>
+              </a:rPr>
+              <a:t>1</a:t>
+            </a:r>
+          </a:p>
+        </p:txBody>
+      </p:sp>
+      <p:sp>
+        <p:nvSpPr>
+          <p:cNvPr id="15" name="TextBox 14"/>
+          <p:cNvSpPr txBox="1"/>
+          <p:nvPr/>
+        </p:nvSpPr>
+        <p:spPr>
+          <a:xfrm>
+            <a:off x="850392" y="2075688"/>
+            <a:ext cx="3048000" cy="237744"/>
+          </a:xfrm>
+          <a:prstGeom prst="rect">
+            <a:avLst/>
+          </a:prstGeom>
+          <a:noFill/>
+        </p:spPr>
+        <p:txBody>
+          <a:bodyPr wrap="square" anchor="ctr">
+            <a:spAutoFit/>
+          </a:bodyPr>
+          <a:lstStyle/>
+          <a:p>
+            <a:pPr algn="l"/>
+            <a:r>
+              <a:rPr sz="1050" b="1">
+                <a:solidFill>
+                  <a:srgbClr val="2D3748"/>
+                </a:solidFill>
+                <a:latin typeface="微软雅黑"/>
+              </a:rPr>
+              <a:t>SRE/AArch64 真机</a:t>
+            </a:r>
+          </a:p>
+        </p:txBody>
+      </p:sp>
+      <p:sp>
+        <p:nvSpPr>
+          <p:cNvPr id="16" name="TextBox 15"/>
+          <p:cNvSpPr txBox="1"/>
+          <p:nvPr/>
+        </p:nvSpPr>
+        <p:spPr>
+          <a:xfrm>
+            <a:off x="850392" y="2322576"/>
+            <a:ext cx="3048000" cy="292608"/>
+          </a:xfrm>
+          <a:prstGeom prst="rect">
+            <a:avLst/>
+          </a:prstGeom>
+          <a:noFill/>
+        </p:spPr>
+        <p:txBody>
+          <a:bodyPr wrap="square" anchor="ctr">
+            <a:spAutoFit/>
+          </a:bodyPr>
+          <a:lstStyle/>
+          <a:p>
+            <a:pPr algn="l"/>
+            <a:r>
+              <a:rPr sz="830" b="0">
+                <a:solidFill>
+                  <a:srgbClr val="595959"/>
+                </a:solidFill>
+                <a:latin typeface="微软雅黑"/>
+              </a:rPr>
+              <a:t>验证跨核共享 worker、裸核链接、平台符号接入</a:t>
+            </a:r>
+          </a:p>
+        </p:txBody>
+      </p:sp>
+      <p:sp>
+        <p:nvSpPr>
+          <p:cNvPr id="17" name="Rectangle 16"/>
+          <p:cNvSpPr/>
+          <p:nvPr/>
+        </p:nvSpPr>
+        <p:spPr>
+          <a:xfrm>
+            <a:off x="320040" y="2743200"/>
+            <a:ext cx="3733800" cy="658368"/>
+          </a:xfrm>
+          <a:prstGeom prst="rect">
+            <a:avLst/>
+          </a:prstGeom>
+          <a:solidFill>
+            <a:srgbClr val="FFFFFF"/>
+          </a:solidFill>
+          <a:ln w="9525">
+            <a:solidFill>
+              <a:srgbClr val="D9DEE6"/>
+            </a:solidFill>
+          </a:ln>
+          <a:effectLst/>
+        </p:spPr>
+        <p:style>
+          <a:lnRef idx="1">
+            <a:schemeClr val="accent1"/>
+          </a:lnRef>
+          <a:fillRef idx="3">
+            <a:schemeClr val="accent1"/>
+          </a:fillRef>
+          <a:effectRef idx="2">
+            <a:schemeClr val="accent1"/>
+          </a:effectRef>
+          <a:fontRef idx="minor">
+            <a:schemeClr val="lt1"/>
+          </a:fontRef>
+        </p:style>
+        <p:txBody>
+          <a:bodyPr rtlCol="0" anchor="ctr"/>
+          <a:lstStyle/>
+          <a:p>
+            <a:pPr algn="ctr"/>
+          </a:p>
+        </p:txBody>
+      </p:sp>
+      <p:sp>
+        <p:nvSpPr>
+          <p:cNvPr id="18" name="Rectangle 17"/>
+          <p:cNvSpPr/>
+          <p:nvPr/>
+        </p:nvSpPr>
+        <p:spPr>
+          <a:xfrm>
+            <a:off x="320040" y="2743200"/>
+            <a:ext cx="64008" cy="658368"/>
+          </a:xfrm>
+          <a:prstGeom prst="rect">
+            <a:avLst/>
+          </a:prstGeom>
+          <a:solidFill>
+            <a:srgbClr val="38A16F"/>
+          </a:solidFill>
+          <a:ln>
+            <a:noFill/>
+          </a:ln>
+          <a:effectLst/>
+        </p:spPr>
+        <p:style>
+          <a:lnRef idx="1">
+            <a:schemeClr val="accent1"/>
+          </a:lnRef>
+          <a:fillRef idx="3">
+            <a:schemeClr val="accent1"/>
+          </a:fillRef>
+          <a:effectRef idx="2">
+            <a:schemeClr val="accent1"/>
+          </a:effectRef>
+          <a:fontRef idx="minor">
+            <a:schemeClr val="lt1"/>
+          </a:fontRef>
+        </p:style>
+        <p:txBody>
+          <a:bodyPr rtlCol="0" anchor="ctr"/>
+          <a:lstStyle/>
+          <a:p>
+            <a:pPr algn="ctr"/>
+          </a:p>
+        </p:txBody>
+      </p:sp>
+      <p:sp>
+        <p:nvSpPr>
+          <p:cNvPr id="19" name="Rectangle 18"/>
+          <p:cNvSpPr/>
+          <p:nvPr/>
+        </p:nvSpPr>
+        <p:spPr>
+          <a:xfrm>
+            <a:off x="466344" y="2871216"/>
+            <a:ext cx="310896" cy="310896"/>
+          </a:xfrm>
+          <a:prstGeom prst="rect">
+            <a:avLst/>
+          </a:prstGeom>
+          <a:solidFill>
+            <a:srgbClr val="38A16F"/>
+          </a:solidFill>
+          <a:ln>
+            <a:noFill/>
+          </a:ln>
+          <a:effectLst/>
+        </p:spPr>
+        <p:style>
+          <a:lnRef idx="1">
+            <a:schemeClr val="accent1"/>
+          </a:lnRef>
+          <a:fillRef idx="3">
+            <a:schemeClr val="accent1"/>
+          </a:fillRef>
+          <a:effectRef idx="2">
+            <a:schemeClr val="accent1"/>
+          </a:effectRef>
+          <a:fontRef idx="minor">
+            <a:schemeClr val="lt1"/>
+          </a:fontRef>
+        </p:style>
+        <p:txBody>
+          <a:bodyPr rtlCol="0" anchor="ctr"/>
+          <a:lstStyle/>
+          <a:p>
+            <a:pPr algn="ctr"/>
+          </a:p>
+        </p:txBody>
+      </p:sp>
+      <p:sp>
+        <p:nvSpPr>
+          <p:cNvPr id="20" name="TextBox 19"/>
+          <p:cNvSpPr txBox="1"/>
+          <p:nvPr/>
+        </p:nvSpPr>
+        <p:spPr>
+          <a:xfrm>
+            <a:off x="466344" y="2871216"/>
+            <a:ext cx="310896" cy="310896"/>
+          </a:xfrm>
+          <a:prstGeom prst="rect">
+            <a:avLst/>
+          </a:prstGeom>
+          <a:noFill/>
+        </p:spPr>
+        <p:txBody>
+          <a:bodyPr wrap="square" anchor="ctr">
+            <a:spAutoFit/>
+          </a:bodyPr>
+          <a:lstStyle/>
+          <a:p>
+            <a:pPr algn="ctr"/>
+            <a:r>
+              <a:rPr sz="950" b="1">
+                <a:solidFill>
+                  <a:srgbClr val="FFFFFF"/>
+                </a:solidFill>
+                <a:latin typeface="微软雅黑"/>
+              </a:rPr>
+              <a:t>2</a:t>
+            </a:r>
+          </a:p>
+        </p:txBody>
+      </p:sp>
+      <p:sp>
+        <p:nvSpPr>
+          <p:cNvPr id="21" name="TextBox 20"/>
+          <p:cNvSpPr txBox="1"/>
+          <p:nvPr/>
+        </p:nvSpPr>
+        <p:spPr>
+          <a:xfrm>
+            <a:off x="850392" y="2807208"/>
+            <a:ext cx="3048000" cy="237744"/>
+          </a:xfrm>
+          <a:prstGeom prst="rect">
+            <a:avLst/>
+          </a:prstGeom>
+          <a:noFill/>
+        </p:spPr>
+        <p:txBody>
+          <a:bodyPr wrap="square" anchor="ctr">
+            <a:spAutoFit/>
+          </a:bodyPr>
+          <a:lstStyle/>
+          <a:p>
+            <a:pPr algn="l"/>
+            <a:r>
+              <a:rPr sz="1050" b="1">
+                <a:solidFill>
+                  <a:srgbClr val="2D3748"/>
+                </a:solidFill>
+                <a:latin typeface="微软雅黑"/>
+              </a:rPr>
+              <a:t>Taskpool 压测</a:t>
+            </a:r>
+          </a:p>
+        </p:txBody>
+      </p:sp>
+      <p:sp>
+        <p:nvSpPr>
+          <p:cNvPr id="22" name="TextBox 21"/>
+          <p:cNvSpPr txBox="1"/>
+          <p:nvPr/>
+        </p:nvSpPr>
+        <p:spPr>
+          <a:xfrm>
+            <a:off x="850392" y="3054096"/>
+            <a:ext cx="3048000" cy="292608"/>
+          </a:xfrm>
+          <a:prstGeom prst="rect">
+            <a:avLst/>
+          </a:prstGeom>
+          <a:noFill/>
+        </p:spPr>
+        <p:txBody>
+          <a:bodyPr wrap="square" anchor="ctr">
+            <a:spAutoFit/>
+          </a:bodyPr>
+          <a:lstStyle/>
+          <a:p>
+            <a:pPr algn="l"/>
+            <a:r>
+              <a:rPr sz="830" b="0">
+                <a:solidFill>
+                  <a:srgbClr val="595959"/>
+                </a:solidFill>
+                <a:latin typeface="微软雅黑"/>
+              </a:rPr>
+              <a:t>MPSC 队列、去重、分桶缓存、version 失效长稳测试</a:t>
+            </a:r>
+          </a:p>
+        </p:txBody>
+      </p:sp>
+      <p:sp>
+        <p:nvSpPr>
+          <p:cNvPr id="23" name="Rectangle 22"/>
+          <p:cNvSpPr/>
+          <p:nvPr/>
+        </p:nvSpPr>
+        <p:spPr>
+          <a:xfrm>
+            <a:off x="320040" y="3474720"/>
+            <a:ext cx="3733800" cy="658368"/>
+          </a:xfrm>
+          <a:prstGeom prst="rect">
+            <a:avLst/>
+          </a:prstGeom>
+          <a:solidFill>
+            <a:srgbClr val="FFFFFF"/>
+          </a:solidFill>
+          <a:ln w="9525">
+            <a:solidFill>
+              <a:srgbClr val="D9DEE6"/>
+            </a:solidFill>
+          </a:ln>
+          <a:effectLst/>
+        </p:spPr>
+        <p:style>
+          <a:lnRef idx="1">
+            <a:schemeClr val="accent1"/>
+          </a:lnRef>
+          <a:fillRef idx="3">
+            <a:schemeClr val="accent1"/>
+          </a:fillRef>
+          <a:effectRef idx="2">
+            <a:schemeClr val="accent1"/>
+          </a:effectRef>
+          <a:fontRef idx="minor">
+            <a:schemeClr val="lt1"/>
+          </a:fontRef>
+        </p:style>
+        <p:txBody>
+          <a:bodyPr rtlCol="0" anchor="ctr"/>
+          <a:lstStyle/>
+          <a:p>
+            <a:pPr algn="ctr"/>
+          </a:p>
+        </p:txBody>
+      </p:sp>
+      <p:sp>
+        <p:nvSpPr>
+          <p:cNvPr id="24" name="Rectangle 23"/>
+          <p:cNvSpPr/>
+          <p:nvPr/>
+        </p:nvSpPr>
+        <p:spPr>
+          <a:xfrm>
+            <a:off x="320040" y="3474720"/>
+            <a:ext cx="64008" cy="658368"/>
+          </a:xfrm>
+          <a:prstGeom prst="rect">
+            <a:avLst/>
+          </a:prstGeom>
+          <a:solidFill>
+            <a:srgbClr val="38A16F"/>
+          </a:solidFill>
+          <a:ln>
+            <a:noFill/>
+          </a:ln>
+          <a:effectLst/>
+        </p:spPr>
+        <p:style>
+          <a:lnRef idx="1">
+            <a:schemeClr val="accent1"/>
+          </a:lnRef>
+          <a:fillRef idx="3">
+            <a:schemeClr val="accent1"/>
+          </a:fillRef>
+          <a:effectRef idx="2">
+            <a:schemeClr val="accent1"/>
+          </a:effectRef>
+          <a:fontRef idx="minor">
+            <a:schemeClr val="lt1"/>
+          </a:fontRef>
+        </p:style>
+        <p:txBody>
+          <a:bodyPr rtlCol="0" anchor="ctr"/>
+          <a:lstStyle/>
+          <a:p>
+            <a:pPr algn="ctr"/>
+          </a:p>
+        </p:txBody>
+      </p:sp>
+      <p:sp>
+        <p:nvSpPr>
+          <p:cNvPr id="25" name="Rectangle 24"/>
+          <p:cNvSpPr/>
+          <p:nvPr/>
+        </p:nvSpPr>
+        <p:spPr>
+          <a:xfrm>
+            <a:off x="466344" y="3602736"/>
+            <a:ext cx="310896" cy="310896"/>
+          </a:xfrm>
+          <a:prstGeom prst="rect">
+            <a:avLst/>
+          </a:prstGeom>
+          <a:solidFill>
+            <a:srgbClr val="38A16F"/>
+          </a:solidFill>
+          <a:ln>
+            <a:noFill/>
+          </a:ln>
+          <a:effectLst/>
+        </p:spPr>
+        <p:style>
+          <a:lnRef idx="1">
+            <a:schemeClr val="accent1"/>
+          </a:lnRef>
+          <a:fillRef idx="3">
+            <a:schemeClr val="accent1"/>
+          </a:fillRef>
+          <a:effectRef idx="2">
+            <a:schemeClr val="accent1"/>
+          </a:effectRef>
+          <a:fontRef idx="minor">
+            <a:schemeClr val="lt1"/>
+          </a:fontRef>
+        </p:style>
+        <p:txBody>
+          <a:bodyPr rtlCol="0" anchor="ctr"/>
+          <a:lstStyle/>
+          <a:p>
+            <a:pPr algn="ctr"/>
+          </a:p>
+        </p:txBody>
+      </p:sp>
+      <p:sp>
+        <p:nvSpPr>
+          <p:cNvPr id="26" name="TextBox 25"/>
+          <p:cNvSpPr txBox="1"/>
+          <p:nvPr/>
+        </p:nvSpPr>
+        <p:spPr>
+          <a:xfrm>
+            <a:off x="466344" y="3602736"/>
+            <a:ext cx="310896" cy="310896"/>
+          </a:xfrm>
+          <a:prstGeom prst="rect">
+            <a:avLst/>
+          </a:prstGeom>
+          <a:noFill/>
+        </p:spPr>
+        <p:txBody>
+          <a:bodyPr wrap="square" anchor="ctr">
+            <a:spAutoFit/>
+          </a:bodyPr>
+          <a:lstStyle/>
+          <a:p>
+            <a:pPr algn="ctr"/>
+            <a:r>
+              <a:rPr sz="950" b="1">
+                <a:solidFill>
+                  <a:srgbClr val="FFFFFF"/>
+                </a:solidFill>
+                <a:latin typeface="微软雅黑"/>
+              </a:rPr>
+              <a:t>3</a:t>
+            </a:r>
+          </a:p>
+        </p:txBody>
+      </p:sp>
+      <p:sp>
+        <p:nvSpPr>
+          <p:cNvPr id="27" name="TextBox 26"/>
+          <p:cNvSpPr txBox="1"/>
+          <p:nvPr/>
+        </p:nvSpPr>
+        <p:spPr>
+          <a:xfrm>
+            <a:off x="850392" y="3538728"/>
+            <a:ext cx="3048000" cy="237744"/>
+          </a:xfrm>
+          <a:prstGeom prst="rect">
+            <a:avLst/>
+          </a:prstGeom>
+          <a:noFill/>
+        </p:spPr>
+        <p:txBody>
+          <a:bodyPr wrap="square" anchor="ctr">
+            <a:spAutoFit/>
+          </a:bodyPr>
+          <a:lstStyle/>
+          <a:p>
+            <a:pPr algn="l"/>
+            <a:r>
+              <a:rPr sz="1050" b="1">
+                <a:solidFill>
+                  <a:srgbClr val="2D3748"/>
+                </a:solidFill>
+                <a:latin typeface="微软雅黑"/>
+              </a:rPr>
+              <a:t>JITLink/CodePool</a:t>
+            </a:r>
+          </a:p>
+        </p:txBody>
+      </p:sp>
+      <p:sp>
+        <p:nvSpPr>
+          <p:cNvPr id="28" name="TextBox 27"/>
+          <p:cNvSpPr txBox="1"/>
+          <p:nvPr/>
+        </p:nvSpPr>
+        <p:spPr>
+          <a:xfrm>
+            <a:off x="850392" y="3785616"/>
+            <a:ext cx="3048000" cy="292608"/>
+          </a:xfrm>
+          <a:prstGeom prst="rect">
+            <a:avLst/>
+          </a:prstGeom>
+          <a:noFill/>
+        </p:spPr>
+        <p:txBody>
+          <a:bodyPr wrap="square" anchor="ctr">
+            <a:spAutoFit/>
+          </a:bodyPr>
+          <a:lstStyle/>
+          <a:p>
+            <a:pPr algn="l"/>
+            <a:r>
+              <a:rPr sz="830" b="0">
+                <a:solidFill>
+                  <a:srgbClr val="595959"/>
+                </a:solidFill>
+                <a:latin typeface="微软雅黑"/>
+              </a:rPr>
+              <a:t>4K/2MiB 池边界、释放策略、失败 fallback 行为</a:t>
+            </a:r>
+          </a:p>
+        </p:txBody>
+      </p:sp>
+      <p:sp>
+        <p:nvSpPr>
+          <p:cNvPr id="29" name="Rectangle 28"/>
+          <p:cNvSpPr/>
+          <p:nvPr/>
+        </p:nvSpPr>
+        <p:spPr>
+          <a:xfrm>
+            <a:off x="320040" y="4206240"/>
+            <a:ext cx="3733800" cy="658368"/>
+          </a:xfrm>
+          <a:prstGeom prst="rect">
+            <a:avLst/>
+          </a:prstGeom>
+          <a:solidFill>
+            <a:srgbClr val="FFFFFF"/>
+          </a:solidFill>
+          <a:ln w="9525">
+            <a:solidFill>
+              <a:srgbClr val="D9DEE6"/>
+            </a:solidFill>
+          </a:ln>
+          <a:effectLst/>
+        </p:spPr>
+        <p:style>
+          <a:lnRef idx="1">
+            <a:schemeClr val="accent1"/>
+          </a:lnRef>
+          <a:fillRef idx="3">
+            <a:schemeClr val="accent1"/>
+          </a:fillRef>
+          <a:effectRef idx="2">
+            <a:schemeClr val="accent1"/>
+          </a:effectRef>
+          <a:fontRef idx="minor">
+            <a:schemeClr val="lt1"/>
+          </a:fontRef>
+        </p:style>
+        <p:txBody>
+          <a:bodyPr rtlCol="0" anchor="ctr"/>
+          <a:lstStyle/>
+          <a:p>
+            <a:pPr algn="ctr"/>
+          </a:p>
+        </p:txBody>
+      </p:sp>
+      <p:sp>
+        <p:nvSpPr>
+          <p:cNvPr id="30" name="Rectangle 29"/>
+          <p:cNvSpPr/>
+          <p:nvPr/>
+        </p:nvSpPr>
+        <p:spPr>
+          <a:xfrm>
+            <a:off x="320040" y="4206240"/>
+            <a:ext cx="64008" cy="658368"/>
+          </a:xfrm>
+          <a:prstGeom prst="rect">
+            <a:avLst/>
+          </a:prstGeom>
+          <a:solidFill>
+            <a:srgbClr val="38A16F"/>
+          </a:solidFill>
+          <a:ln>
+            <a:noFill/>
+          </a:ln>
+          <a:effectLst/>
+        </p:spPr>
+        <p:style>
+          <a:lnRef idx="1">
+            <a:schemeClr val="accent1"/>
+          </a:lnRef>
+          <a:fillRef idx="3">
+            <a:schemeClr val="accent1"/>
+          </a:fillRef>
+          <a:effectRef idx="2">
+            <a:schemeClr val="accent1"/>
+          </a:effectRef>
+          <a:fontRef idx="minor">
+            <a:schemeClr val="lt1"/>
+          </a:fontRef>
+        </p:style>
+        <p:txBody>
+          <a:bodyPr rtlCol="0" anchor="ctr"/>
+          <a:lstStyle/>
+          <a:p>
+            <a:pPr algn="ctr"/>
+          </a:p>
+        </p:txBody>
+      </p:sp>
+      <p:sp>
+        <p:nvSpPr>
+          <p:cNvPr id="31" name="Rectangle 30"/>
+          <p:cNvSpPr/>
+          <p:nvPr/>
+        </p:nvSpPr>
+        <p:spPr>
+          <a:xfrm>
+            <a:off x="466344" y="4334256"/>
+            <a:ext cx="310896" cy="310896"/>
+          </a:xfrm>
+          <a:prstGeom prst="rect">
+            <a:avLst/>
+          </a:prstGeom>
+          <a:solidFill>
+            <a:srgbClr val="38A16F"/>
+          </a:solidFill>
+          <a:ln>
+            <a:noFill/>
+          </a:ln>
+          <a:effectLst/>
+        </p:spPr>
+        <p:style>
+          <a:lnRef idx="1">
+            <a:schemeClr val="accent1"/>
+          </a:lnRef>
+          <a:fillRef idx="3">
+            <a:schemeClr val="accent1"/>
+          </a:fillRef>
+          <a:effectRef idx="2">
+            <a:schemeClr val="accent1"/>
+          </a:effectRef>
+          <a:fontRef idx="minor">
+            <a:schemeClr val="lt1"/>
+          </a:fontRef>
+        </p:style>
+        <p:txBody>
+          <a:bodyPr rtlCol="0" anchor="ctr"/>
+          <a:lstStyle/>
+          <a:p>
+            <a:pPr algn="ctr"/>
+          </a:p>
+        </p:txBody>
+      </p:sp>
+      <p:sp>
+        <p:nvSpPr>
+          <p:cNvPr id="32" name="TextBox 31"/>
+          <p:cNvSpPr txBox="1"/>
+          <p:nvPr/>
+        </p:nvSpPr>
+        <p:spPr>
+          <a:xfrm>
+            <a:off x="466344" y="4334256"/>
+            <a:ext cx="310896" cy="310896"/>
+          </a:xfrm>
+          <a:prstGeom prst="rect">
+            <a:avLst/>
+          </a:prstGeom>
+          <a:noFill/>
+        </p:spPr>
+        <p:txBody>
+          <a:bodyPr wrap="square" anchor="ctr">
+            <a:spAutoFit/>
+          </a:bodyPr>
+          <a:lstStyle/>
+          <a:p>
+            <a:pPr algn="ctr"/>
+            <a:r>
+              <a:rPr sz="950" b="1">
+                <a:solidFill>
+                  <a:srgbClr val="FFFFFF"/>
+                </a:solidFill>
+                <a:latin typeface="微软雅黑"/>
+              </a:rPr>
+              <a:t>4</a:t>
+            </a:r>
+          </a:p>
+        </p:txBody>
+      </p:sp>
+      <p:sp>
+        <p:nvSpPr>
+          <p:cNvPr id="33" name="TextBox 32"/>
+          <p:cNvSpPr txBox="1"/>
+          <p:nvPr/>
+        </p:nvSpPr>
+        <p:spPr>
+          <a:xfrm>
+            <a:off x="850392" y="4270248"/>
+            <a:ext cx="3048000" cy="237744"/>
+          </a:xfrm>
+          <a:prstGeom prst="rect">
+            <a:avLst/>
+          </a:prstGeom>
+          <a:noFill/>
+        </p:spPr>
+        <p:txBody>
+          <a:bodyPr wrap="square" anchor="ctr">
+            <a:spAutoFit/>
+          </a:bodyPr>
+          <a:lstStyle/>
+          <a:p>
+            <a:pPr algn="l"/>
+            <a:r>
+              <a:rPr sz="1050" b="1">
+                <a:solidFill>
+                  <a:srgbClr val="2D3748"/>
+                </a:solidFill>
+                <a:latin typeface="微软雅黑"/>
+              </a:rPr>
+              <a:t>端到端 Demo</a:t>
+            </a:r>
+          </a:p>
+        </p:txBody>
+      </p:sp>
+      <p:sp>
+        <p:nvSpPr>
+          <p:cNvPr id="34" name="TextBox 33"/>
+          <p:cNvSpPr txBox="1"/>
+          <p:nvPr/>
+        </p:nvSpPr>
+        <p:spPr>
+          <a:xfrm>
+            <a:off x="850392" y="4517136"/>
+            <a:ext cx="3048000" cy="292608"/>
+          </a:xfrm>
+          <a:prstGeom prst="rect">
+            <a:avLst/>
+          </a:prstGeom>
+          <a:noFill/>
+        </p:spPr>
+        <p:txBody>
+          <a:bodyPr wrap="square" anchor="ctr">
+            <a:spAutoFit/>
+          </a:bodyPr>
+          <a:lstStyle/>
+          <a:p>
+            <a:pPr algn="l"/>
+            <a:r>
+              <a:rPr sz="830" b="0">
+                <a:solidFill>
+                  <a:srgbClr val="595959"/>
+                </a:solidFill>
+                <a:latin typeface="微软雅黑"/>
+              </a:rPr>
+              <a:t>从属性标注到运行时特化的可复现实验脚本</a:t>
+            </a:r>
+          </a:p>
+        </p:txBody>
+      </p:sp>
+      <p:sp>
+        <p:nvSpPr>
+          <p:cNvPr id="35" name="Rectangle 34"/>
+          <p:cNvSpPr/>
+          <p:nvPr/>
+        </p:nvSpPr>
+        <p:spPr>
+          <a:xfrm>
+            <a:off x="4236720" y="1508760"/>
+            <a:ext cx="3733800" cy="384048"/>
+          </a:xfrm>
+          <a:prstGeom prst="rect">
+            <a:avLst/>
+          </a:prstGeom>
+          <a:solidFill>
+            <a:srgbClr val="3182CE"/>
+          </a:solidFill>
+          <a:ln>
+            <a:noFill/>
+          </a:ln>
+          <a:effectLst/>
+        </p:spPr>
+        <p:style>
+          <a:lnRef idx="1">
+            <a:schemeClr val="accent1"/>
+          </a:lnRef>
+          <a:fillRef idx="3">
+            <a:schemeClr val="accent1"/>
+          </a:fillRef>
+          <a:effectRef idx="2">
+            <a:schemeClr val="accent1"/>
+          </a:effectRef>
+          <a:fontRef idx="minor">
+            <a:schemeClr val="lt1"/>
+          </a:fontRef>
+        </p:style>
+        <p:txBody>
+          <a:bodyPr rtlCol="0" anchor="ctr"/>
+          <a:lstStyle/>
+          <a:p>
+            <a:pPr algn="ctr"/>
+          </a:p>
+        </p:txBody>
+      </p:sp>
+      <p:sp>
+        <p:nvSpPr>
+          <p:cNvPr id="36" name="TextBox 35"/>
+          <p:cNvSpPr txBox="1"/>
+          <p:nvPr/>
+        </p:nvSpPr>
+        <p:spPr>
+          <a:xfrm>
+            <a:off x="4346448" y="1508760"/>
+            <a:ext cx="3514344" cy="384048"/>
+          </a:xfrm>
+          <a:prstGeom prst="rect">
+            <a:avLst/>
+          </a:prstGeom>
+          <a:noFill/>
+        </p:spPr>
+        <p:txBody>
+          <a:bodyPr wrap="square" anchor="ctr">
+            <a:spAutoFit/>
+          </a:bodyPr>
+          <a:lstStyle/>
+          <a:p>
+            <a:pPr algn="l"/>
+            <a:r>
+              <a:rPr sz="1200" b="1">
+                <a:solidFill>
+                  <a:srgbClr val="FFFFFF"/>
+                </a:solidFill>
+                <a:latin typeface="微软雅黑"/>
+              </a:rPr>
+              <a:t>中期：收益量化</a:t>
+            </a:r>
+            <a:r>
+              <a:rPr sz="1000" b="0">
+                <a:solidFill>
+                  <a:srgbClr val="FFFFFF"/>
+                </a:solidFill>
+                <a:latin typeface="微软雅黑"/>
+              </a:rPr>
+              <a:t>  ·  </a:t>
+            </a:r>
+            <a:r>
+              <a:rPr sz="1000" b="1">
+                <a:solidFill>
+                  <a:srgbClr val="E8F2FF"/>
+                </a:solidFill>
+                <a:latin typeface="微软雅黑"/>
+              </a:rPr>
+              <a:t>1~2 月</a:t>
+            </a:r>
+          </a:p>
+        </p:txBody>
+      </p:sp>
+      <p:sp>
+        <p:nvSpPr>
+          <p:cNvPr id="37" name="Rectangle 36"/>
+          <p:cNvSpPr/>
+          <p:nvPr/>
+        </p:nvSpPr>
+        <p:spPr>
+          <a:xfrm>
+            <a:off x="4236720" y="2011680"/>
+            <a:ext cx="3733800" cy="658368"/>
+          </a:xfrm>
+          <a:prstGeom prst="rect">
+            <a:avLst/>
+          </a:prstGeom>
+          <a:solidFill>
+            <a:srgbClr val="FFFFFF"/>
+          </a:solidFill>
+          <a:ln w="9525">
+            <a:solidFill>
+              <a:srgbClr val="D9DEE6"/>
+            </a:solidFill>
+          </a:ln>
+          <a:effectLst/>
+        </p:spPr>
+        <p:style>
+          <a:lnRef idx="1">
+            <a:schemeClr val="accent1"/>
+          </a:lnRef>
+          <a:fillRef idx="3">
+            <a:schemeClr val="accent1"/>
+          </a:fillRef>
+          <a:effectRef idx="2">
+            <a:schemeClr val="accent1"/>
+          </a:effectRef>
+          <a:fontRef idx="minor">
+            <a:schemeClr val="lt1"/>
+          </a:fontRef>
+        </p:style>
+        <p:txBody>
+          <a:bodyPr rtlCol="0" anchor="ctr"/>
+          <a:lstStyle/>
+          <a:p>
+            <a:pPr algn="ctr"/>
+          </a:p>
+        </p:txBody>
+      </p:sp>
+      <p:sp>
+        <p:nvSpPr>
+          <p:cNvPr id="38" name="Rectangle 37"/>
+          <p:cNvSpPr/>
+          <p:nvPr/>
+        </p:nvSpPr>
+        <p:spPr>
+          <a:xfrm>
+            <a:off x="4236720" y="2011680"/>
+            <a:ext cx="64008" cy="658368"/>
+          </a:xfrm>
+          <a:prstGeom prst="rect">
+            <a:avLst/>
+          </a:prstGeom>
+          <a:solidFill>
+            <a:srgbClr val="3182CE"/>
+          </a:solidFill>
+          <a:ln>
+            <a:noFill/>
+          </a:ln>
+          <a:effectLst/>
+        </p:spPr>
+        <p:style>
+          <a:lnRef idx="1">
+            <a:schemeClr val="accent1"/>
+          </a:lnRef>
+          <a:fillRef idx="3">
+            <a:schemeClr val="accent1"/>
+          </a:fillRef>
+          <a:effectRef idx="2">
+            <a:schemeClr val="accent1"/>
+          </a:effectRef>
+          <a:fontRef idx="minor">
+            <a:schemeClr val="lt1"/>
+          </a:fontRef>
+        </p:style>
+        <p:txBody>
+          <a:bodyPr rtlCol="0" anchor="ctr"/>
+          <a:lstStyle/>
+          <a:p>
+            <a:pPr algn="ctr"/>
+          </a:p>
+        </p:txBody>
+      </p:sp>
+      <p:sp>
+        <p:nvSpPr>
+          <p:cNvPr id="39" name="Rectangle 38"/>
+          <p:cNvSpPr/>
+          <p:nvPr/>
+        </p:nvSpPr>
+        <p:spPr>
+          <a:xfrm>
+            <a:off x="4383024" y="2139696"/>
+            <a:ext cx="310896" cy="310896"/>
+          </a:xfrm>
+          <a:prstGeom prst="rect">
+            <a:avLst/>
+          </a:prstGeom>
+          <a:solidFill>
+            <a:srgbClr val="3182CE"/>
+          </a:solidFill>
+          <a:ln>
+            <a:noFill/>
+          </a:ln>
+          <a:effectLst/>
+        </p:spPr>
+        <p:style>
+          <a:lnRef idx="1">
+            <a:schemeClr val="accent1"/>
+          </a:lnRef>
+          <a:fillRef idx="3">
+            <a:schemeClr val="accent1"/>
+          </a:fillRef>
+          <a:effectRef idx="2">
+            <a:schemeClr val="accent1"/>
+          </a:effectRef>
+          <a:fontRef idx="minor">
+            <a:schemeClr val="lt1"/>
+          </a:fontRef>
+        </p:style>
+        <p:txBody>
+          <a:bodyPr rtlCol="0" anchor="ctr"/>
+          <a:lstStyle/>
+          <a:p>
+            <a:pPr algn="ctr"/>
+          </a:p>
+        </p:txBody>
+      </p:sp>
+      <p:sp>
+        <p:nvSpPr>
+          <p:cNvPr id="40" name="TextBox 39"/>
+          <p:cNvSpPr txBox="1"/>
+          <p:nvPr/>
+        </p:nvSpPr>
+        <p:spPr>
+          <a:xfrm>
+            <a:off x="4383024" y="2139696"/>
+            <a:ext cx="310896" cy="310896"/>
+          </a:xfrm>
+          <a:prstGeom prst="rect">
+            <a:avLst/>
+          </a:prstGeom>
+          <a:noFill/>
+        </p:spPr>
+        <p:txBody>
+          <a:bodyPr wrap="square" anchor="ctr">
+            <a:spAutoFit/>
+          </a:bodyPr>
+          <a:lstStyle/>
+          <a:p>
+            <a:pPr algn="ctr"/>
+            <a:r>
+              <a:rPr sz="950" b="1">
+                <a:solidFill>
+                  <a:srgbClr val="FFFFFF"/>
+                </a:solidFill>
+                <a:latin typeface="微软雅黑"/>
+              </a:rPr>
+              <a:t>1</a:t>
+            </a:r>
+          </a:p>
+        </p:txBody>
+      </p:sp>
+      <p:sp>
+        <p:nvSpPr>
+          <p:cNvPr id="41" name="TextBox 40"/>
+          <p:cNvSpPr txBox="1"/>
+          <p:nvPr/>
+        </p:nvSpPr>
+        <p:spPr>
+          <a:xfrm>
+            <a:off x="4767072" y="2075688"/>
+            <a:ext cx="3048000" cy="237744"/>
+          </a:xfrm>
+          <a:prstGeom prst="rect">
+            <a:avLst/>
+          </a:prstGeom>
+          <a:noFill/>
+        </p:spPr>
+        <p:txBody>
+          <a:bodyPr wrap="square" anchor="ctr">
+            <a:spAutoFit/>
+          </a:bodyPr>
+          <a:lstStyle/>
+          <a:p>
+            <a:pPr algn="l"/>
+            <a:r>
+              <a:rPr sz="1050" b="1">
+                <a:solidFill>
+                  <a:srgbClr val="2D3748"/>
+                </a:solidFill>
+                <a:latin typeface="微软雅黑"/>
+              </a:rPr>
+              <a:t>Benchmark 体系</a:t>
+            </a:r>
+          </a:p>
+        </p:txBody>
+      </p:sp>
+      <p:sp>
+        <p:nvSpPr>
+          <p:cNvPr id="42" name="TextBox 41"/>
+          <p:cNvSpPr txBox="1"/>
+          <p:nvPr/>
+        </p:nvSpPr>
+        <p:spPr>
+          <a:xfrm>
+            <a:off x="4767072" y="2322576"/>
+            <a:ext cx="3048000" cy="292608"/>
+          </a:xfrm>
+          <a:prstGeom prst="rect">
+            <a:avLst/>
+          </a:prstGeom>
+          <a:noFill/>
+        </p:spPr>
+        <p:txBody>
+          <a:bodyPr wrap="square" anchor="ctr">
+            <a:spAutoFit/>
+          </a:bodyPr>
+          <a:lstStyle/>
+          <a:p>
+            <a:pPr algn="l"/>
+            <a:r>
+              <a:rPr sz="830" b="0">
+                <a:solidFill>
+                  <a:srgbClr val="595959"/>
+                </a:solidFill>
+                <a:latin typeface="微软雅黑"/>
+              </a:rPr>
+              <a:t>zlib/zstd/业务 kernel: cold/hot/命中率/编译耗时</a:t>
+            </a:r>
+          </a:p>
+        </p:txBody>
+      </p:sp>
+      <p:sp>
+        <p:nvSpPr>
+          <p:cNvPr id="43" name="Rectangle 42"/>
+          <p:cNvSpPr/>
+          <p:nvPr/>
+        </p:nvSpPr>
+        <p:spPr>
+          <a:xfrm>
+            <a:off x="4236720" y="2743200"/>
+            <a:ext cx="3733800" cy="658368"/>
+          </a:xfrm>
+          <a:prstGeom prst="rect">
+            <a:avLst/>
+          </a:prstGeom>
+          <a:solidFill>
+            <a:srgbClr val="FFFFFF"/>
+          </a:solidFill>
+          <a:ln w="9525">
+            <a:solidFill>
+              <a:srgbClr val="D9DEE6"/>
+            </a:solidFill>
+          </a:ln>
+          <a:effectLst/>
+        </p:spPr>
+        <p:style>
+          <a:lnRef idx="1">
+            <a:schemeClr val="accent1"/>
+          </a:lnRef>
+          <a:fillRef idx="3">
+            <a:schemeClr val="accent1"/>
+          </a:fillRef>
+          <a:effectRef idx="2">
+            <a:schemeClr val="accent1"/>
+          </a:effectRef>
+          <a:fontRef idx="minor">
+            <a:schemeClr val="lt1"/>
+          </a:fontRef>
+        </p:style>
+        <p:txBody>
+          <a:bodyPr rtlCol="0" anchor="ctr"/>
+          <a:lstStyle/>
+          <a:p>
+            <a:pPr algn="ctr"/>
+          </a:p>
+        </p:txBody>
+      </p:sp>
+      <p:sp>
+        <p:nvSpPr>
+          <p:cNvPr id="44" name="Rectangle 43"/>
+          <p:cNvSpPr/>
+          <p:nvPr/>
+        </p:nvSpPr>
+        <p:spPr>
+          <a:xfrm>
+            <a:off x="4236720" y="2743200"/>
+            <a:ext cx="64008" cy="658368"/>
+          </a:xfrm>
+          <a:prstGeom prst="rect">
+            <a:avLst/>
+          </a:prstGeom>
+          <a:solidFill>
+            <a:srgbClr val="3182CE"/>
+          </a:solidFill>
+          <a:ln>
+            <a:noFill/>
+          </a:ln>
+          <a:effectLst/>
+        </p:spPr>
+        <p:style>
+          <a:lnRef idx="1">
+            <a:schemeClr val="accent1"/>
+          </a:lnRef>
+          <a:fillRef idx="3">
+            <a:schemeClr val="accent1"/>
+          </a:fillRef>
+          <a:effectRef idx="2">
+            <a:schemeClr val="accent1"/>
+          </a:effectRef>
+          <a:fontRef idx="minor">
+            <a:schemeClr val="lt1"/>
+          </a:fontRef>
+        </p:style>
+        <p:txBody>
+          <a:bodyPr rtlCol="0" anchor="ctr"/>
+          <a:lstStyle/>
+          <a:p>
+            <a:pPr algn="ctr"/>
+          </a:p>
+        </p:txBody>
+      </p:sp>
+      <p:sp>
+        <p:nvSpPr>
+          <p:cNvPr id="45" name="Rectangle 44"/>
+          <p:cNvSpPr/>
+          <p:nvPr/>
+        </p:nvSpPr>
+        <p:spPr>
+          <a:xfrm>
+            <a:off x="4383024" y="2871216"/>
+            <a:ext cx="310896" cy="310896"/>
+          </a:xfrm>
+          <a:prstGeom prst="rect">
+            <a:avLst/>
+          </a:prstGeom>
+          <a:solidFill>
+            <a:srgbClr val="3182CE"/>
+          </a:solidFill>
+          <a:ln>
+            <a:noFill/>
+          </a:ln>
+          <a:effectLst/>
+        </p:spPr>
+        <p:style>
+          <a:lnRef idx="1">
+            <a:schemeClr val="accent1"/>
+          </a:lnRef>
+          <a:fillRef idx="3">
+            <a:schemeClr val="accent1"/>
+          </a:fillRef>
+          <a:effectRef idx="2">
+            <a:schemeClr val="accent1"/>
+          </a:effectRef>
+          <a:fontRef idx="minor">
+            <a:schemeClr val="lt1"/>
+          </a:fontRef>
+        </p:style>
+        <p:txBody>
+          <a:bodyPr rtlCol="0" anchor="ctr"/>
+          <a:lstStyle/>
+          <a:p>
+            <a:pPr algn="ctr"/>
+          </a:p>
+        </p:txBody>
+      </p:sp>
+      <p:sp>
+        <p:nvSpPr>
+          <p:cNvPr id="46" name="TextBox 45"/>
+          <p:cNvSpPr txBox="1"/>
+          <p:nvPr/>
+        </p:nvSpPr>
+        <p:spPr>
+          <a:xfrm>
+            <a:off x="4383024" y="2871216"/>
+            <a:ext cx="310896" cy="310896"/>
+          </a:xfrm>
+          <a:prstGeom prst="rect">
+            <a:avLst/>
+          </a:prstGeom>
+          <a:noFill/>
+        </p:spPr>
+        <p:txBody>
+          <a:bodyPr wrap="square" anchor="ctr">
+            <a:spAutoFit/>
+          </a:bodyPr>
+          <a:lstStyle/>
+          <a:p>
+            <a:pPr algn="ctr"/>
+            <a:r>
+              <a:rPr sz="950" b="1">
+                <a:solidFill>
+                  <a:srgbClr val="FFFFFF"/>
+                </a:solidFill>
+                <a:latin typeface="微软雅黑"/>
+              </a:rPr>
+              <a:t>2</a:t>
+            </a:r>
+          </a:p>
+        </p:txBody>
+      </p:sp>
+      <p:sp>
+        <p:nvSpPr>
+          <p:cNvPr id="47" name="TextBox 46"/>
+          <p:cNvSpPr txBox="1"/>
+          <p:nvPr/>
+        </p:nvSpPr>
+        <p:spPr>
+          <a:xfrm>
+            <a:off x="4767072" y="2807208"/>
+            <a:ext cx="3048000" cy="237744"/>
+          </a:xfrm>
+          <a:prstGeom prst="rect">
+            <a:avLst/>
+          </a:prstGeom>
+          <a:noFill/>
+        </p:spPr>
+        <p:txBody>
+          <a:bodyPr wrap="square" anchor="ctr">
+            <a:spAutoFit/>
+          </a:bodyPr>
+          <a:lstStyle/>
+          <a:p>
+            <a:pPr algn="l"/>
+            <a:r>
+              <a:rPr sz="1050" b="1">
+                <a:solidFill>
+                  <a:srgbClr val="2D3748"/>
+                </a:solidFill>
+                <a:latin typeface="微软雅黑"/>
+              </a:rPr>
+              <a:t>PASS6 增强</a:t>
+            </a:r>
+          </a:p>
+        </p:txBody>
+      </p:sp>
+      <p:sp>
+        <p:nvSpPr>
+          <p:cNvPr id="48" name="TextBox 47"/>
+          <p:cNvSpPr txBox="1"/>
+          <p:nvPr/>
+        </p:nvSpPr>
+        <p:spPr>
+          <a:xfrm>
+            <a:off x="4767072" y="3054096"/>
+            <a:ext cx="3048000" cy="292608"/>
+          </a:xfrm>
+          <a:prstGeom prst="rect">
+            <a:avLst/>
+          </a:prstGeom>
+          <a:noFill/>
+        </p:spPr>
+        <p:txBody>
+          <a:bodyPr wrap="square" anchor="ctr">
+            <a:spAutoFit/>
+          </a:bodyPr>
+          <a:lstStyle/>
+          <a:p>
+            <a:pPr algn="l"/>
+            <a:r>
+              <a:rPr sz="830" b="0">
+                <a:solidFill>
+                  <a:srgbClr val="595959"/>
+                </a:solidFill>
+                <a:latin typeface="微软雅黑"/>
+              </a:rPr>
+              <a:t>数组/嵌套结构/volatile/别名场景覆盖与收益分析</a:t>
+            </a:r>
+          </a:p>
+        </p:txBody>
+      </p:sp>
+      <p:sp>
+        <p:nvSpPr>
+          <p:cNvPr id="49" name="Rectangle 48"/>
+          <p:cNvSpPr/>
+          <p:nvPr/>
+        </p:nvSpPr>
+        <p:spPr>
+          <a:xfrm>
+            <a:off x="4236720" y="3474720"/>
+            <a:ext cx="3733800" cy="658368"/>
+          </a:xfrm>
+          <a:prstGeom prst="rect">
+            <a:avLst/>
+          </a:prstGeom>
+          <a:solidFill>
+            <a:srgbClr val="FFFFFF"/>
+          </a:solidFill>
+          <a:ln w="9525">
+            <a:solidFill>
+              <a:srgbClr val="D9DEE6"/>
+            </a:solidFill>
+          </a:ln>
+          <a:effectLst/>
+        </p:spPr>
+        <p:style>
+          <a:lnRef idx="1">
+            <a:schemeClr val="accent1"/>
+          </a:lnRef>
+          <a:fillRef idx="3">
+            <a:schemeClr val="accent1"/>
+          </a:fillRef>
+          <a:effectRef idx="2">
+            <a:schemeClr val="accent1"/>
+          </a:effectRef>
+          <a:fontRef idx="minor">
+            <a:schemeClr val="lt1"/>
+          </a:fontRef>
+        </p:style>
+        <p:txBody>
+          <a:bodyPr rtlCol="0" anchor="ctr"/>
+          <a:lstStyle/>
+          <a:p>
+            <a:pPr algn="ctr"/>
+          </a:p>
+        </p:txBody>
+      </p:sp>
+      <p:sp>
+        <p:nvSpPr>
+          <p:cNvPr id="50" name="Rectangle 49"/>
+          <p:cNvSpPr/>
+          <p:nvPr/>
+        </p:nvSpPr>
+        <p:spPr>
+          <a:xfrm>
+            <a:off x="4236720" y="3474720"/>
+            <a:ext cx="64008" cy="658368"/>
+          </a:xfrm>
+          <a:prstGeom prst="rect">
+            <a:avLst/>
+          </a:prstGeom>
+          <a:solidFill>
+            <a:srgbClr val="3182CE"/>
+          </a:solidFill>
+          <a:ln>
+            <a:noFill/>
+          </a:ln>
+          <a:effectLst/>
+        </p:spPr>
+        <p:style>
+          <a:lnRef idx="1">
+            <a:schemeClr val="accent1"/>
+          </a:lnRef>
+          <a:fillRef idx="3">
+            <a:schemeClr val="accent1"/>
+          </a:fillRef>
+          <a:effectRef idx="2">
+            <a:schemeClr val="accent1"/>
+          </a:effectRef>
+          <a:fontRef idx="minor">
+            <a:schemeClr val="lt1"/>
+          </a:fontRef>
+        </p:style>
+        <p:txBody>
+          <a:bodyPr rtlCol="0" anchor="ctr"/>
+          <a:lstStyle/>
+          <a:p>
+            <a:pPr algn="ctr"/>
+          </a:p>
+        </p:txBody>
+      </p:sp>
+      <p:sp>
+        <p:nvSpPr>
+          <p:cNvPr id="51" name="Rectangle 50"/>
+          <p:cNvSpPr/>
+          <p:nvPr/>
+        </p:nvSpPr>
+        <p:spPr>
+          <a:xfrm>
+            <a:off x="4383024" y="3602736"/>
+            <a:ext cx="310896" cy="310896"/>
+          </a:xfrm>
+          <a:prstGeom prst="rect">
+            <a:avLst/>
+          </a:prstGeom>
+          <a:solidFill>
+            <a:srgbClr val="3182CE"/>
+          </a:solidFill>
+          <a:ln>
+            <a:noFill/>
+          </a:ln>
+          <a:effectLst/>
+        </p:spPr>
+        <p:style>
+          <a:lnRef idx="1">
+            <a:schemeClr val="accent1"/>
+          </a:lnRef>
+          <a:fillRef idx="3">
+            <a:schemeClr val="accent1"/>
+          </a:fillRef>
+          <a:effectRef idx="2">
+            <a:schemeClr val="accent1"/>
+          </a:effectRef>
+          <a:fontRef idx="minor">
+            <a:schemeClr val="lt1"/>
+          </a:fontRef>
+        </p:style>
+        <p:txBody>
+          <a:bodyPr rtlCol="0" anchor="ctr"/>
+          <a:lstStyle/>
+          <a:p>
+            <a:pPr algn="ctr"/>
+          </a:p>
+        </p:txBody>
+      </p:sp>
+      <p:sp>
+        <p:nvSpPr>
+          <p:cNvPr id="52" name="TextBox 51"/>
+          <p:cNvSpPr txBox="1"/>
+          <p:nvPr/>
+        </p:nvSpPr>
+        <p:spPr>
+          <a:xfrm>
+            <a:off x="4383024" y="3602736"/>
+            <a:ext cx="310896" cy="310896"/>
+          </a:xfrm>
+          <a:prstGeom prst="rect">
+            <a:avLst/>
+          </a:prstGeom>
+          <a:noFill/>
+        </p:spPr>
+        <p:txBody>
+          <a:bodyPr wrap="square" anchor="ctr">
+            <a:spAutoFit/>
+          </a:bodyPr>
+          <a:lstStyle/>
+          <a:p>
+            <a:pPr algn="ctr"/>
+            <a:r>
+              <a:rPr sz="950" b="1">
+                <a:solidFill>
+                  <a:srgbClr val="FFFFFF"/>
+                </a:solidFill>
+                <a:latin typeface="微软雅黑"/>
+              </a:rPr>
+              <a:t>3</a:t>
+            </a:r>
+          </a:p>
+        </p:txBody>
+      </p:sp>
+      <p:sp>
+        <p:nvSpPr>
+          <p:cNvPr id="53" name="TextBox 52"/>
+          <p:cNvSpPr txBox="1"/>
+          <p:nvPr/>
+        </p:nvSpPr>
+        <p:spPr>
+          <a:xfrm>
+            <a:off x="4767072" y="3538728"/>
+            <a:ext cx="3048000" cy="237744"/>
+          </a:xfrm>
+          <a:prstGeom prst="rect">
+            <a:avLst/>
+          </a:prstGeom>
+          <a:noFill/>
+        </p:spPr>
+        <p:txBody>
+          <a:bodyPr wrap="square" anchor="ctr">
+            <a:spAutoFit/>
+          </a:bodyPr>
+          <a:lstStyle/>
+          <a:p>
+            <a:pPr algn="l"/>
+            <a:r>
+              <a:rPr sz="1050" b="1">
+                <a:solidFill>
+                  <a:srgbClr val="2D3748"/>
+                </a:solidFill>
+                <a:latin typeface="微软雅黑"/>
+              </a:rPr>
+              <a:t>调参策略</a:t>
+            </a:r>
+          </a:p>
+        </p:txBody>
+      </p:sp>
+      <p:sp>
+        <p:nvSpPr>
+          <p:cNvPr id="54" name="TextBox 53"/>
+          <p:cNvSpPr txBox="1"/>
+          <p:nvPr/>
+        </p:nvSpPr>
+        <p:spPr>
+          <a:xfrm>
+            <a:off x="4767072" y="3785616"/>
+            <a:ext cx="3048000" cy="292608"/>
+          </a:xfrm>
+          <a:prstGeom prst="rect">
+            <a:avLst/>
+          </a:prstGeom>
+          <a:noFill/>
+        </p:spPr>
+        <p:txBody>
+          <a:bodyPr wrap="square" anchor="ctr">
+            <a:spAutoFit/>
+          </a:bodyPr>
+          <a:lstStyle/>
+          <a:p>
+            <a:pPr algn="l"/>
+            <a:r>
+              <a:rPr sz="830" b="0">
+                <a:solidFill>
+                  <a:srgbClr val="595959"/>
+                </a:solidFill>
+                <a:latin typeface="微软雅黑"/>
+              </a:rPr>
+              <a:t>L1/L2/L3 pipeline、缓存上限、异步编译触发阈值</a:t>
+            </a:r>
+          </a:p>
+        </p:txBody>
+      </p:sp>
+      <p:sp>
+        <p:nvSpPr>
+          <p:cNvPr id="55" name="Rectangle 54"/>
+          <p:cNvSpPr/>
+          <p:nvPr/>
+        </p:nvSpPr>
+        <p:spPr>
+          <a:xfrm>
+            <a:off x="4236720" y="4206240"/>
+            <a:ext cx="3733800" cy="658368"/>
+          </a:xfrm>
+          <a:prstGeom prst="rect">
+            <a:avLst/>
+          </a:prstGeom>
+          <a:solidFill>
+            <a:srgbClr val="FFFFFF"/>
+          </a:solidFill>
+          <a:ln w="9525">
+            <a:solidFill>
+              <a:srgbClr val="D9DEE6"/>
+            </a:solidFill>
+          </a:ln>
+          <a:effectLst/>
+        </p:spPr>
+        <p:style>
+          <a:lnRef idx="1">
+            <a:schemeClr val="accent1"/>
+          </a:lnRef>
+          <a:fillRef idx="3">
+            <a:schemeClr val="accent1"/>
+          </a:fillRef>
+          <a:effectRef idx="2">
+            <a:schemeClr val="accent1"/>
+          </a:effectRef>
+          <a:fontRef idx="minor">
+            <a:schemeClr val="lt1"/>
+          </a:fontRef>
+        </p:style>
+        <p:txBody>
+          <a:bodyPr rtlCol="0" anchor="ctr"/>
+          <a:lstStyle/>
+          <a:p>
+            <a:pPr algn="ctr"/>
+          </a:p>
+        </p:txBody>
+      </p:sp>
+      <p:sp>
+        <p:nvSpPr>
+          <p:cNvPr id="56" name="Rectangle 55"/>
+          <p:cNvSpPr/>
+          <p:nvPr/>
+        </p:nvSpPr>
+        <p:spPr>
+          <a:xfrm>
+            <a:off x="4236720" y="4206240"/>
+            <a:ext cx="64008" cy="658368"/>
+          </a:xfrm>
+          <a:prstGeom prst="rect">
+            <a:avLst/>
+          </a:prstGeom>
+          <a:solidFill>
+            <a:srgbClr val="3182CE"/>
+          </a:solidFill>
+          <a:ln>
+            <a:noFill/>
+          </a:ln>
+          <a:effectLst/>
+        </p:spPr>
+        <p:style>
+          <a:lnRef idx="1">
+            <a:schemeClr val="accent1"/>
+          </a:lnRef>
+          <a:fillRef idx="3">
+            <a:schemeClr val="accent1"/>
+          </a:fillRef>
+          <a:effectRef idx="2">
+            <a:schemeClr val="accent1"/>
+          </a:effectRef>
+          <a:fontRef idx="minor">
+            <a:schemeClr val="lt1"/>
+          </a:fontRef>
+        </p:style>
+        <p:txBody>
+          <a:bodyPr rtlCol="0" anchor="ctr"/>
+          <a:lstStyle/>
+          <a:p>
+            <a:pPr algn="ctr"/>
+          </a:p>
+        </p:txBody>
+      </p:sp>
+      <p:sp>
+        <p:nvSpPr>
+          <p:cNvPr id="57" name="Rectangle 56"/>
+          <p:cNvSpPr/>
+          <p:nvPr/>
+        </p:nvSpPr>
+        <p:spPr>
+          <a:xfrm>
+            <a:off x="4383024" y="4334256"/>
+            <a:ext cx="310896" cy="310896"/>
+          </a:xfrm>
+          <a:prstGeom prst="rect">
+            <a:avLst/>
+          </a:prstGeom>
+          <a:solidFill>
+            <a:srgbClr val="3182CE"/>
+          </a:solidFill>
+          <a:ln>
+            <a:noFill/>
+          </a:ln>
+          <a:effectLst/>
+        </p:spPr>
+        <p:style>
+          <a:lnRef idx="1">
+            <a:schemeClr val="accent1"/>
+          </a:lnRef>
+          <a:fillRef idx="3">
+            <a:schemeClr val="accent1"/>
+          </a:fillRef>
+          <a:effectRef idx="2">
+            <a:schemeClr val="accent1"/>
+          </a:effectRef>
+          <a:fontRef idx="minor">
+            <a:schemeClr val="lt1"/>
+          </a:fontRef>
+        </p:style>
+        <p:txBody>
+          <a:bodyPr rtlCol="0" anchor="ctr"/>
+          <a:lstStyle/>
+          <a:p>
+            <a:pPr algn="ctr"/>
+          </a:p>
+        </p:txBody>
+      </p:sp>
+      <p:sp>
+        <p:nvSpPr>
+          <p:cNvPr id="58" name="TextBox 57"/>
+          <p:cNvSpPr txBox="1"/>
+          <p:nvPr/>
+        </p:nvSpPr>
+        <p:spPr>
+          <a:xfrm>
+            <a:off x="4383024" y="4334256"/>
+            <a:ext cx="310896" cy="310896"/>
+          </a:xfrm>
+          <a:prstGeom prst="rect">
+            <a:avLst/>
+          </a:prstGeom>
+          <a:noFill/>
+        </p:spPr>
+        <p:txBody>
+          <a:bodyPr wrap="square" anchor="ctr">
+            <a:spAutoFit/>
+          </a:bodyPr>
+          <a:lstStyle/>
+          <a:p>
+            <a:pPr algn="ctr"/>
+            <a:r>
+              <a:rPr sz="950" b="1">
+                <a:solidFill>
+                  <a:srgbClr val="FFFFFF"/>
+                </a:solidFill>
+                <a:latin typeface="微软雅黑"/>
+              </a:rPr>
+              <a:t>4</a:t>
+            </a:r>
+          </a:p>
+        </p:txBody>
+      </p:sp>
+      <p:sp>
+        <p:nvSpPr>
+          <p:cNvPr id="59" name="TextBox 58"/>
+          <p:cNvSpPr txBox="1"/>
+          <p:nvPr/>
+        </p:nvSpPr>
+        <p:spPr>
+          <a:xfrm>
+            <a:off x="4767072" y="4270248"/>
+            <a:ext cx="3048000" cy="237744"/>
+          </a:xfrm>
+          <a:prstGeom prst="rect">
+            <a:avLst/>
+          </a:prstGeom>
+          <a:noFill/>
+        </p:spPr>
+        <p:txBody>
+          <a:bodyPr wrap="square" anchor="ctr">
+            <a:spAutoFit/>
+          </a:bodyPr>
+          <a:lstStyle/>
+          <a:p>
+            <a:pPr algn="l"/>
+            <a:r>
+              <a:rPr sz="1050" b="1">
+                <a:solidFill>
+                  <a:srgbClr val="2D3748"/>
+                </a:solidFill>
+                <a:latin typeface="微软雅黑"/>
+              </a:rPr>
+              <a:t>裁剪体积</a:t>
+            </a:r>
+          </a:p>
+        </p:txBody>
+      </p:sp>
+      <p:sp>
+        <p:nvSpPr>
+          <p:cNvPr id="60" name="TextBox 59"/>
+          <p:cNvSpPr txBox="1"/>
+          <p:nvPr/>
+        </p:nvSpPr>
+        <p:spPr>
+          <a:xfrm>
+            <a:off x="4767072" y="4517136"/>
+            <a:ext cx="3048000" cy="292608"/>
+          </a:xfrm>
+          <a:prstGeom prst="rect">
+            <a:avLst/>
+          </a:prstGeom>
+          <a:noFill/>
+        </p:spPr>
+        <p:txBody>
+          <a:bodyPr wrap="square" anchor="ctr">
+            <a:spAutoFit/>
+          </a:bodyPr>
+          <a:lstStyle/>
+          <a:p>
+            <a:pPr algn="l"/>
+            <a:r>
+              <a:rPr sz="830" b="0">
+                <a:solidFill>
+                  <a:srgbClr val="595959"/>
+                </a:solidFill>
+                <a:latin typeface="微软雅黑"/>
+              </a:rPr>
+              <a:t>单 ejit.o 继续瘦身: PassBuilder/Target/JITLink 依赖收敛</a:t>
+            </a:r>
+          </a:p>
+        </p:txBody>
+      </p:sp>
+      <p:sp>
+        <p:nvSpPr>
+          <p:cNvPr id="61" name="Rectangle 60"/>
+          <p:cNvSpPr/>
+          <p:nvPr/>
+        </p:nvSpPr>
+        <p:spPr>
+          <a:xfrm>
+            <a:off x="8153400" y="1508760"/>
+            <a:ext cx="3733800" cy="384048"/>
+          </a:xfrm>
+          <a:prstGeom prst="rect">
+            <a:avLst/>
+          </a:prstGeom>
+          <a:solidFill>
+            <a:srgbClr val="2C5282"/>
+          </a:solidFill>
+          <a:ln>
+            <a:noFill/>
+          </a:ln>
+          <a:effectLst/>
+        </p:spPr>
+        <p:style>
+          <a:lnRef idx="1">
+            <a:schemeClr val="accent1"/>
+          </a:lnRef>
+          <a:fillRef idx="3">
+            <a:schemeClr val="accent1"/>
+          </a:fillRef>
+          <a:effectRef idx="2">
+            <a:schemeClr val="accent1"/>
+          </a:effectRef>
+          <a:fontRef idx="minor">
+            <a:schemeClr val="lt1"/>
+          </a:fontRef>
+        </p:style>
+        <p:txBody>
+          <a:bodyPr rtlCol="0" anchor="ctr"/>
+          <a:lstStyle/>
+          <a:p>
+            <a:pPr algn="ctr"/>
+          </a:p>
+        </p:txBody>
+      </p:sp>
+      <p:sp>
+        <p:nvSpPr>
+          <p:cNvPr id="62" name="TextBox 61"/>
+          <p:cNvSpPr txBox="1"/>
+          <p:nvPr/>
+        </p:nvSpPr>
+        <p:spPr>
+          <a:xfrm>
+            <a:off x="8263128" y="1508760"/>
+            <a:ext cx="3514344" cy="384048"/>
+          </a:xfrm>
+          <a:prstGeom prst="rect">
+            <a:avLst/>
+          </a:prstGeom>
+          <a:noFill/>
+        </p:spPr>
+        <p:txBody>
+          <a:bodyPr wrap="square" anchor="ctr">
+            <a:spAutoFit/>
+          </a:bodyPr>
+          <a:lstStyle/>
+          <a:p>
+            <a:pPr algn="l"/>
+            <a:r>
+              <a:rPr sz="1200" b="1">
+                <a:solidFill>
+                  <a:srgbClr val="FFFFFF"/>
+                </a:solidFill>
+                <a:latin typeface="微软雅黑"/>
+              </a:rPr>
+              <a:t>远期：工程交付</a:t>
+            </a:r>
+            <a:r>
+              <a:rPr sz="1000" b="0">
+                <a:solidFill>
+                  <a:srgbClr val="FFFFFF"/>
+                </a:solidFill>
+                <a:latin typeface="微软雅黑"/>
+              </a:rPr>
+              <a:t>  ·  </a:t>
+            </a:r>
+            <a:r>
+              <a:rPr sz="1000" b="1">
+                <a:solidFill>
+                  <a:srgbClr val="E8F2FF"/>
+                </a:solidFill>
+                <a:latin typeface="微软雅黑"/>
+              </a:rPr>
+              <a:t>季度</a:t>
+            </a:r>
+          </a:p>
+        </p:txBody>
+      </p:sp>
+      <p:sp>
+        <p:nvSpPr>
+          <p:cNvPr id="63" name="Rectangle 62"/>
+          <p:cNvSpPr/>
+          <p:nvPr/>
+        </p:nvSpPr>
+        <p:spPr>
+          <a:xfrm>
+            <a:off x="8153400" y="2011680"/>
+            <a:ext cx="3733800" cy="658368"/>
+          </a:xfrm>
+          <a:prstGeom prst="rect">
+            <a:avLst/>
+          </a:prstGeom>
+          <a:solidFill>
+            <a:srgbClr val="FFFFFF"/>
+          </a:solidFill>
+          <a:ln w="9525">
+            <a:solidFill>
+              <a:srgbClr val="D9DEE6"/>
+            </a:solidFill>
+          </a:ln>
+          <a:effectLst/>
+        </p:spPr>
+        <p:style>
+          <a:lnRef idx="1">
+            <a:schemeClr val="accent1"/>
+          </a:lnRef>
+          <a:fillRef idx="3">
+            <a:schemeClr val="accent1"/>
+          </a:fillRef>
+          <a:effectRef idx="2">
+            <a:schemeClr val="accent1"/>
+          </a:effectRef>
+          <a:fontRef idx="minor">
+            <a:schemeClr val="lt1"/>
+          </a:fontRef>
+        </p:style>
+        <p:txBody>
+          <a:bodyPr rtlCol="0" anchor="ctr"/>
+          <a:lstStyle/>
+          <a:p>
+            <a:pPr algn="ctr"/>
+          </a:p>
+        </p:txBody>
+      </p:sp>
+      <p:sp>
+        <p:nvSpPr>
+          <p:cNvPr id="64" name="Rectangle 63"/>
+          <p:cNvSpPr/>
+          <p:nvPr/>
+        </p:nvSpPr>
+        <p:spPr>
+          <a:xfrm>
+            <a:off x="8153400" y="2011680"/>
+            <a:ext cx="64008" cy="658368"/>
+          </a:xfrm>
+          <a:prstGeom prst="rect">
+            <a:avLst/>
+          </a:prstGeom>
+          <a:solidFill>
+            <a:srgbClr val="2C5282"/>
+          </a:solidFill>
+          <a:ln>
+            <a:noFill/>
+          </a:ln>
+          <a:effectLst/>
+        </p:spPr>
+        <p:style>
+          <a:lnRef idx="1">
+            <a:schemeClr val="accent1"/>
+          </a:lnRef>
+          <a:fillRef idx="3">
+            <a:schemeClr val="accent1"/>
+          </a:fillRef>
+          <a:effectRef idx="2">
+            <a:schemeClr val="accent1"/>
+          </a:effectRef>
+          <a:fontRef idx="minor">
+            <a:schemeClr val="lt1"/>
+          </a:fontRef>
+        </p:style>
+        <p:txBody>
+          <a:bodyPr rtlCol="0" anchor="ctr"/>
+          <a:lstStyle/>
+          <a:p>
+            <a:pPr algn="ctr"/>
+          </a:p>
+        </p:txBody>
+      </p:sp>
+      <p:sp>
+        <p:nvSpPr>
+          <p:cNvPr id="65" name="Rectangle 64"/>
+          <p:cNvSpPr/>
+          <p:nvPr/>
+        </p:nvSpPr>
+        <p:spPr>
+          <a:xfrm>
+            <a:off x="8299704" y="2139696"/>
+            <a:ext cx="310896" cy="310896"/>
+          </a:xfrm>
+          <a:prstGeom prst="rect">
+            <a:avLst/>
+          </a:prstGeom>
+          <a:solidFill>
+            <a:srgbClr val="2C5282"/>
+          </a:solidFill>
+          <a:ln>
+            <a:noFill/>
+          </a:ln>
+          <a:effectLst/>
+        </p:spPr>
+        <p:style>
+          <a:lnRef idx="1">
+            <a:schemeClr val="accent1"/>
+          </a:lnRef>
+          <a:fillRef idx="3">
+            <a:schemeClr val="accent1"/>
+          </a:fillRef>
+          <a:effectRef idx="2">
+            <a:schemeClr val="accent1"/>
+          </a:effectRef>
+          <a:fontRef idx="minor">
+            <a:schemeClr val="lt1"/>
+          </a:fontRef>
+        </p:style>
+        <p:txBody>
+          <a:bodyPr rtlCol="0" anchor="ctr"/>
+          <a:lstStyle/>
+          <a:p>
+            <a:pPr algn="ctr"/>
+          </a:p>
+        </p:txBody>
+      </p:sp>
+      <p:sp>
+        <p:nvSpPr>
+          <p:cNvPr id="66" name="TextBox 65"/>
+          <p:cNvSpPr txBox="1"/>
+          <p:nvPr/>
+        </p:nvSpPr>
+        <p:spPr>
+          <a:xfrm>
+            <a:off x="8299704" y="2139696"/>
+            <a:ext cx="310896" cy="310896"/>
+          </a:xfrm>
+          <a:prstGeom prst="rect">
+            <a:avLst/>
+          </a:prstGeom>
+          <a:noFill/>
+        </p:spPr>
+        <p:txBody>
+          <a:bodyPr wrap="square" anchor="ctr">
+            <a:spAutoFit/>
+          </a:bodyPr>
+          <a:lstStyle/>
+          <a:p>
+            <a:pPr algn="ctr"/>
+            <a:r>
+              <a:rPr sz="950" b="1">
+                <a:solidFill>
+                  <a:srgbClr val="FFFFFF"/>
+                </a:solidFill>
+                <a:latin typeface="微软雅黑"/>
+              </a:rPr>
+              <a:t>1</a:t>
+            </a:r>
+          </a:p>
+        </p:txBody>
+      </p:sp>
+      <p:sp>
+        <p:nvSpPr>
+          <p:cNvPr id="67" name="TextBox 66"/>
+          <p:cNvSpPr txBox="1"/>
+          <p:nvPr/>
+        </p:nvSpPr>
+        <p:spPr>
+          <a:xfrm>
+            <a:off x="8683752" y="2075688"/>
+            <a:ext cx="3048000" cy="237744"/>
+          </a:xfrm>
+          <a:prstGeom prst="rect">
+            <a:avLst/>
+          </a:prstGeom>
+          <a:noFill/>
+        </p:spPr>
+        <p:txBody>
+          <a:bodyPr wrap="square" anchor="ctr">
+            <a:spAutoFit/>
+          </a:bodyPr>
+          <a:lstStyle/>
+          <a:p>
+            <a:pPr algn="l"/>
+            <a:r>
+              <a:rPr sz="1050" b="1">
+                <a:solidFill>
+                  <a:srgbClr val="2D3748"/>
+                </a:solidFill>
+                <a:latin typeface="微软雅黑"/>
+              </a:rPr>
+              <a:t>平台抽象固化</a:t>
+            </a:r>
+          </a:p>
+        </p:txBody>
+      </p:sp>
+      <p:sp>
+        <p:nvSpPr>
+          <p:cNvPr id="68" name="TextBox 67"/>
+          <p:cNvSpPr txBox="1"/>
+          <p:nvPr/>
+        </p:nvSpPr>
+        <p:spPr>
+          <a:xfrm>
+            <a:off x="8683752" y="2322576"/>
+            <a:ext cx="3048000" cy="292608"/>
+          </a:xfrm>
+          <a:prstGeom prst="rect">
+            <a:avLst/>
+          </a:prstGeom>
+          <a:noFill/>
+        </p:spPr>
+        <p:txBody>
+          <a:bodyPr wrap="square" anchor="ctr">
+            <a:spAutoFit/>
+          </a:bodyPr>
+          <a:lstStyle/>
+          <a:p>
+            <a:pPr algn="l"/>
+            <a:r>
+              <a:rPr sz="830" b="0">
+                <a:solidFill>
+                  <a:srgbClr val="595959"/>
+                </a:solidFill>
+                <a:latin typeface="微软雅黑"/>
+              </a:rPr>
+              <a:t>host/SRE/bare-metal 三套配置稳定化与文档化</a:t>
+            </a:r>
+          </a:p>
+        </p:txBody>
+      </p:sp>
+      <p:sp>
+        <p:nvSpPr>
+          <p:cNvPr id="69" name="Rectangle 68"/>
+          <p:cNvSpPr/>
+          <p:nvPr/>
+        </p:nvSpPr>
+        <p:spPr>
+          <a:xfrm>
+            <a:off x="8153400" y="2743200"/>
+            <a:ext cx="3733800" cy="658368"/>
+          </a:xfrm>
+          <a:prstGeom prst="rect">
+            <a:avLst/>
+          </a:prstGeom>
+          <a:solidFill>
+            <a:srgbClr val="FFFFFF"/>
+          </a:solidFill>
+          <a:ln w="9525">
+            <a:solidFill>
+              <a:srgbClr val="D9DEE6"/>
+            </a:solidFill>
+          </a:ln>
+          <a:effectLst/>
+        </p:spPr>
+        <p:style>
+          <a:lnRef idx="1">
+            <a:schemeClr val="accent1"/>
+          </a:lnRef>
+          <a:fillRef idx="3">
+            <a:schemeClr val="accent1"/>
+          </a:fillRef>
+          <a:effectRef idx="2">
+            <a:schemeClr val="accent1"/>
+          </a:effectRef>
+          <a:fontRef idx="minor">
+            <a:schemeClr val="lt1"/>
+          </a:fontRef>
+        </p:style>
+        <p:txBody>
+          <a:bodyPr rtlCol="0" anchor="ctr"/>
+          <a:lstStyle/>
+          <a:p>
+            <a:pPr algn="ctr"/>
+          </a:p>
+        </p:txBody>
+      </p:sp>
+      <p:sp>
+        <p:nvSpPr>
+          <p:cNvPr id="70" name="Rectangle 69"/>
+          <p:cNvSpPr/>
+          <p:nvPr/>
+        </p:nvSpPr>
+        <p:spPr>
+          <a:xfrm>
+            <a:off x="8153400" y="2743200"/>
+            <a:ext cx="64008" cy="658368"/>
+          </a:xfrm>
+          <a:prstGeom prst="rect">
+            <a:avLst/>
+          </a:prstGeom>
+          <a:solidFill>
+            <a:srgbClr val="2C5282"/>
+          </a:solidFill>
+          <a:ln>
+            <a:noFill/>
+          </a:ln>
+          <a:effectLst/>
+        </p:spPr>
+        <p:style>
+          <a:lnRef idx="1">
+            <a:schemeClr val="accent1"/>
+          </a:lnRef>
+          <a:fillRef idx="3">
+            <a:schemeClr val="accent1"/>
+          </a:fillRef>
+          <a:effectRef idx="2">
+            <a:schemeClr val="accent1"/>
+          </a:effectRef>
+          <a:fontRef idx="minor">
+            <a:schemeClr val="lt1"/>
+          </a:fontRef>
+        </p:style>
+        <p:txBody>
+          <a:bodyPr rtlCol="0" anchor="ctr"/>
+          <a:lstStyle/>
+          <a:p>
+            <a:pPr algn="ctr"/>
+          </a:p>
+        </p:txBody>
+      </p:sp>
+      <p:sp>
+        <p:nvSpPr>
+          <p:cNvPr id="71" name="Rectangle 70"/>
+          <p:cNvSpPr/>
+          <p:nvPr/>
+        </p:nvSpPr>
+        <p:spPr>
+          <a:xfrm>
+            <a:off x="8299704" y="2871216"/>
+            <a:ext cx="310896" cy="310896"/>
+          </a:xfrm>
+          <a:prstGeom prst="rect">
+            <a:avLst/>
+          </a:prstGeom>
+          <a:solidFill>
+            <a:srgbClr val="2C5282"/>
+          </a:solidFill>
+          <a:ln>
+            <a:noFill/>
+          </a:ln>
+          <a:effectLst/>
+        </p:spPr>
+        <p:style>
+          <a:lnRef idx="1">
+            <a:schemeClr val="accent1"/>
+          </a:lnRef>
+          <a:fillRef idx="3">
+            <a:schemeClr val="accent1"/>
+          </a:fillRef>
+          <a:effectRef idx="2">
+            <a:schemeClr val="accent1"/>
+          </a:effectRef>
+          <a:fontRef idx="minor">
+            <a:schemeClr val="lt1"/>
+          </a:fontRef>
+        </p:style>
+        <p:txBody>
+          <a:bodyPr rtlCol="0" anchor="ctr"/>
+          <a:lstStyle/>
+          <a:p>
+            <a:pPr algn="ctr"/>
+          </a:p>
+        </p:txBody>
+      </p:sp>
+      <p:sp>
+        <p:nvSpPr>
+          <p:cNvPr id="72" name="TextBox 71"/>
+          <p:cNvSpPr txBox="1"/>
+          <p:nvPr/>
+        </p:nvSpPr>
+        <p:spPr>
+          <a:xfrm>
+            <a:off x="8299704" y="2871216"/>
+            <a:ext cx="310896" cy="310896"/>
+          </a:xfrm>
+          <a:prstGeom prst="rect">
+            <a:avLst/>
+          </a:prstGeom>
+          <a:noFill/>
+        </p:spPr>
+        <p:txBody>
+          <a:bodyPr wrap="square" anchor="ctr">
+            <a:spAutoFit/>
+          </a:bodyPr>
+          <a:lstStyle/>
+          <a:p>
+            <a:pPr algn="ctr"/>
+            <a:r>
+              <a:rPr sz="950" b="1">
+                <a:solidFill>
+                  <a:srgbClr val="FFFFFF"/>
+                </a:solidFill>
+                <a:latin typeface="微软雅黑"/>
+              </a:rPr>
+              <a:t>2</a:t>
+            </a:r>
+          </a:p>
+        </p:txBody>
+      </p:sp>
+      <p:sp>
+        <p:nvSpPr>
+          <p:cNvPr id="73" name="TextBox 72"/>
+          <p:cNvSpPr txBox="1"/>
+          <p:nvPr/>
+        </p:nvSpPr>
+        <p:spPr>
+          <a:xfrm>
+            <a:off x="8683752" y="2807208"/>
+            <a:ext cx="3048000" cy="237744"/>
+          </a:xfrm>
+          <a:prstGeom prst="rect">
+            <a:avLst/>
+          </a:prstGeom>
+          <a:noFill/>
+        </p:spPr>
+        <p:txBody>
+          <a:bodyPr wrap="square" anchor="ctr">
+            <a:spAutoFit/>
+          </a:bodyPr>
+          <a:lstStyle/>
+          <a:p>
+            <a:pPr algn="l"/>
+            <a:r>
+              <a:rPr sz="1050" b="1">
+                <a:solidFill>
+                  <a:srgbClr val="2D3748"/>
+                </a:solidFill>
+                <a:latin typeface="微软雅黑"/>
+              </a:rPr>
+              <a:t>诊断与可观测</a:t>
+            </a:r>
+          </a:p>
+        </p:txBody>
+      </p:sp>
+      <p:sp>
+        <p:nvSpPr>
+          <p:cNvPr id="74" name="TextBox 73"/>
+          <p:cNvSpPr txBox="1"/>
+          <p:nvPr/>
+        </p:nvSpPr>
+        <p:spPr>
+          <a:xfrm>
+            <a:off x="8683752" y="3054096"/>
+            <a:ext cx="3048000" cy="292608"/>
+          </a:xfrm>
+          <a:prstGeom prst="rect">
+            <a:avLst/>
+          </a:prstGeom>
+          <a:noFill/>
+        </p:spPr>
+        <p:txBody>
+          <a:bodyPr wrap="square" anchor="ctr">
+            <a:spAutoFit/>
+          </a:bodyPr>
+          <a:lstStyle/>
+          <a:p>
+            <a:pPr algn="l"/>
+            <a:r>
+              <a:rPr sz="830" b="0">
+                <a:solidFill>
+                  <a:srgbClr val="595959"/>
+                </a:solidFill>
+                <a:latin typeface="微软雅黑"/>
+              </a:rPr>
+              <a:t>trace/dump/错误码/统计 counters 统一输出</a:t>
+            </a:r>
+          </a:p>
+        </p:txBody>
+      </p:sp>
+      <p:sp>
+        <p:nvSpPr>
+          <p:cNvPr id="75" name="Rectangle 74"/>
+          <p:cNvSpPr/>
+          <p:nvPr/>
+        </p:nvSpPr>
+        <p:spPr>
+          <a:xfrm>
+            <a:off x="8153400" y="3474720"/>
+            <a:ext cx="3733800" cy="658368"/>
+          </a:xfrm>
+          <a:prstGeom prst="rect">
+            <a:avLst/>
+          </a:prstGeom>
+          <a:solidFill>
+            <a:srgbClr val="FFFFFF"/>
+          </a:solidFill>
+          <a:ln w="9525">
+            <a:solidFill>
+              <a:srgbClr val="D9DEE6"/>
+            </a:solidFill>
+          </a:ln>
+          <a:effectLst/>
+        </p:spPr>
+        <p:style>
+          <a:lnRef idx="1">
+            <a:schemeClr val="accent1"/>
+          </a:lnRef>
+          <a:fillRef idx="3">
+            <a:schemeClr val="accent1"/>
+          </a:fillRef>
+          <a:effectRef idx="2">
+            <a:schemeClr val="accent1"/>
+          </a:effectRef>
+          <a:fontRef idx="minor">
+            <a:schemeClr val="lt1"/>
+          </a:fontRef>
+        </p:style>
+        <p:txBody>
+          <a:bodyPr rtlCol="0" anchor="ctr"/>
+          <a:lstStyle/>
+          <a:p>
+            <a:pPr algn="ctr"/>
+          </a:p>
+        </p:txBody>
+      </p:sp>
+      <p:sp>
+        <p:nvSpPr>
+          <p:cNvPr id="76" name="Rectangle 75"/>
+          <p:cNvSpPr/>
+          <p:nvPr/>
+        </p:nvSpPr>
+        <p:spPr>
+          <a:xfrm>
+            <a:off x="8153400" y="3474720"/>
+            <a:ext cx="64008" cy="658368"/>
+          </a:xfrm>
+          <a:prstGeom prst="rect">
+            <a:avLst/>
+          </a:prstGeom>
+          <a:solidFill>
+            <a:srgbClr val="2C5282"/>
+          </a:solidFill>
+          <a:ln>
+            <a:noFill/>
+          </a:ln>
+          <a:effectLst/>
+        </p:spPr>
+        <p:style>
+          <a:lnRef idx="1">
+            <a:schemeClr val="accent1"/>
+          </a:lnRef>
+          <a:fillRef idx="3">
+            <a:schemeClr val="accent1"/>
+          </a:fillRef>
+          <a:effectRef idx="2">
+            <a:schemeClr val="accent1"/>
+          </a:effectRef>
+          <a:fontRef idx="minor">
+            <a:schemeClr val="lt1"/>
+          </a:fontRef>
+        </p:style>
+        <p:txBody>
+          <a:bodyPr rtlCol="0" anchor="ctr"/>
+          <a:lstStyle/>
+          <a:p>
+            <a:pPr algn="ctr"/>
+          </a:p>
+        </p:txBody>
+      </p:sp>
+      <p:sp>
+        <p:nvSpPr>
+          <p:cNvPr id="77" name="Rectangle 76"/>
+          <p:cNvSpPr/>
+          <p:nvPr/>
+        </p:nvSpPr>
+        <p:spPr>
+          <a:xfrm>
+            <a:off x="8299704" y="3602736"/>
+            <a:ext cx="310896" cy="310896"/>
+          </a:xfrm>
+          <a:prstGeom prst="rect">
+            <a:avLst/>
+          </a:prstGeom>
+          <a:solidFill>
+            <a:srgbClr val="2C5282"/>
+          </a:solidFill>
+          <a:ln>
+            <a:noFill/>
+          </a:ln>
+          <a:effectLst/>
+        </p:spPr>
+        <p:style>
+          <a:lnRef idx="1">
+            <a:schemeClr val="accent1"/>
+          </a:lnRef>
+          <a:fillRef idx="3">
+            <a:schemeClr val="accent1"/>
+          </a:fillRef>
+          <a:effectRef idx="2">
+            <a:schemeClr val="accent1"/>
+          </a:effectRef>
+          <a:fontRef idx="minor">
+            <a:schemeClr val="lt1"/>
+          </a:fontRef>
+        </p:style>
+        <p:txBody>
+          <a:bodyPr rtlCol="0" anchor="ctr"/>
+          <a:lstStyle/>
+          <a:p>
+            <a:pPr algn="ctr"/>
+          </a:p>
+        </p:txBody>
+      </p:sp>
+      <p:sp>
+        <p:nvSpPr>
+          <p:cNvPr id="78" name="TextBox 77"/>
+          <p:cNvSpPr txBox="1"/>
+          <p:nvPr/>
+        </p:nvSpPr>
+        <p:spPr>
+          <a:xfrm>
+            <a:off x="8299704" y="3602736"/>
+            <a:ext cx="310896" cy="310896"/>
+          </a:xfrm>
+          <a:prstGeom prst="rect">
+            <a:avLst/>
+          </a:prstGeom>
+          <a:noFill/>
+        </p:spPr>
+        <p:txBody>
+          <a:bodyPr wrap="square" anchor="ctr">
+            <a:spAutoFit/>
+          </a:bodyPr>
+          <a:lstStyle/>
+          <a:p>
+            <a:pPr algn="ctr"/>
+            <a:r>
+              <a:rPr sz="950" b="1">
+                <a:solidFill>
+                  <a:srgbClr val="FFFFFF"/>
+                </a:solidFill>
+                <a:latin typeface="微软雅黑"/>
+              </a:rPr>
+              <a:t>3</a:t>
+            </a:r>
+          </a:p>
+        </p:txBody>
+      </p:sp>
+      <p:sp>
+        <p:nvSpPr>
+          <p:cNvPr id="79" name="TextBox 78"/>
+          <p:cNvSpPr txBox="1"/>
+          <p:nvPr/>
+        </p:nvSpPr>
+        <p:spPr>
+          <a:xfrm>
+            <a:off x="8683752" y="3538728"/>
+            <a:ext cx="3048000" cy="237744"/>
+          </a:xfrm>
+          <a:prstGeom prst="rect">
+            <a:avLst/>
+          </a:prstGeom>
+          <a:noFill/>
+        </p:spPr>
+        <p:txBody>
+          <a:bodyPr wrap="square" anchor="ctr">
+            <a:spAutoFit/>
+          </a:bodyPr>
+          <a:lstStyle/>
+          <a:p>
+            <a:pPr algn="l"/>
+            <a:r>
+              <a:rPr sz="1050" b="1">
+                <a:solidFill>
+                  <a:srgbClr val="2D3748"/>
+                </a:solidFill>
+                <a:latin typeface="微软雅黑"/>
+              </a:rPr>
+              <a:t>安全护栏</a:t>
+            </a:r>
+          </a:p>
+        </p:txBody>
+      </p:sp>
+      <p:sp>
+        <p:nvSpPr>
+          <p:cNvPr id="80" name="TextBox 79"/>
+          <p:cNvSpPr txBox="1"/>
+          <p:nvPr/>
+        </p:nvSpPr>
+        <p:spPr>
+          <a:xfrm>
+            <a:off x="8683752" y="3785616"/>
+            <a:ext cx="3048000" cy="292608"/>
+          </a:xfrm>
+          <a:prstGeom prst="rect">
+            <a:avLst/>
+          </a:prstGeom>
+          <a:noFill/>
+        </p:spPr>
+        <p:txBody>
+          <a:bodyPr wrap="square" anchor="ctr">
+            <a:spAutoFit/>
+          </a:bodyPr>
+          <a:lstStyle/>
+          <a:p>
+            <a:pPr algn="l"/>
+            <a:r>
+              <a:rPr sz="830" b="0">
+                <a:solidFill>
+                  <a:srgbClr val="595959"/>
+                </a:solidFill>
+                <a:latin typeface="微软雅黑"/>
+              </a:rPr>
+              <a:t>注册冻结、符号白名单、内存权限切换与越界保护</a:t>
+            </a:r>
+          </a:p>
+        </p:txBody>
+      </p:sp>
+      <p:sp>
+        <p:nvSpPr>
+          <p:cNvPr id="81" name="Rectangle 80"/>
+          <p:cNvSpPr/>
+          <p:nvPr/>
+        </p:nvSpPr>
+        <p:spPr>
+          <a:xfrm>
+            <a:off x="8153400" y="4206240"/>
+            <a:ext cx="3733800" cy="658368"/>
+          </a:xfrm>
+          <a:prstGeom prst="rect">
+            <a:avLst/>
+          </a:prstGeom>
+          <a:solidFill>
+            <a:srgbClr val="FFFFFF"/>
+          </a:solidFill>
+          <a:ln w="9525">
+            <a:solidFill>
+              <a:srgbClr val="D9DEE6"/>
+            </a:solidFill>
+          </a:ln>
+          <a:effectLst/>
+        </p:spPr>
+        <p:style>
+          <a:lnRef idx="1">
+            <a:schemeClr val="accent1"/>
+          </a:lnRef>
+          <a:fillRef idx="3">
+            <a:schemeClr val="accent1"/>
+          </a:fillRef>
+          <a:effectRef idx="2">
+            <a:schemeClr val="accent1"/>
+          </a:effectRef>
+          <a:fontRef idx="minor">
+            <a:schemeClr val="lt1"/>
+          </a:fontRef>
+        </p:style>
+        <p:txBody>
+          <a:bodyPr rtlCol="0" anchor="ctr"/>
+          <a:lstStyle/>
+          <a:p>
+            <a:pPr algn="ctr"/>
+          </a:p>
+        </p:txBody>
+      </p:sp>
+      <p:sp>
+        <p:nvSpPr>
+          <p:cNvPr id="82" name="Rectangle 81"/>
+          <p:cNvSpPr/>
+          <p:nvPr/>
+        </p:nvSpPr>
+        <p:spPr>
+          <a:xfrm>
+            <a:off x="8153400" y="4206240"/>
+            <a:ext cx="64008" cy="658368"/>
+          </a:xfrm>
+          <a:prstGeom prst="rect">
+            <a:avLst/>
+          </a:prstGeom>
+          <a:solidFill>
+            <a:srgbClr val="2C5282"/>
+          </a:solidFill>
+          <a:ln>
+            <a:noFill/>
+          </a:ln>
+          <a:effectLst/>
+        </p:spPr>
+        <p:style>
+          <a:lnRef idx="1">
+            <a:schemeClr val="accent1"/>
+          </a:lnRef>
+          <a:fillRef idx="3">
+            <a:schemeClr val="accent1"/>
+          </a:fillRef>
+          <a:effectRef idx="2">
+            <a:schemeClr val="accent1"/>
+          </a:effectRef>
+          <a:fontRef idx="minor">
+            <a:schemeClr val="lt1"/>
+          </a:fontRef>
+        </p:style>
+        <p:txBody>
+          <a:bodyPr rtlCol="0" anchor="ctr"/>
+          <a:lstStyle/>
+          <a:p>
+            <a:pPr algn="ctr"/>
+          </a:p>
+        </p:txBody>
+      </p:sp>
+      <p:sp>
+        <p:nvSpPr>
+          <p:cNvPr id="83" name="Rectangle 82"/>
+          <p:cNvSpPr/>
+          <p:nvPr/>
+        </p:nvSpPr>
+        <p:spPr>
+          <a:xfrm>
+            <a:off x="8299704" y="4334256"/>
+            <a:ext cx="310896" cy="310896"/>
+          </a:xfrm>
+          <a:prstGeom prst="rect">
+            <a:avLst/>
+          </a:prstGeom>
+          <a:solidFill>
+            <a:srgbClr val="2C5282"/>
+          </a:solidFill>
+          <a:ln>
+            <a:noFill/>
+          </a:ln>
+          <a:effectLst/>
+        </p:spPr>
+        <p:style>
+          <a:lnRef idx="1">
+            <a:schemeClr val="accent1"/>
+          </a:lnRef>
+          <a:fillRef idx="3">
+            <a:schemeClr val="accent1"/>
+          </a:fillRef>
+          <a:effectRef idx="2">
+            <a:schemeClr val="accent1"/>
+          </a:effectRef>
+          <a:fontRef idx="minor">
+            <a:schemeClr val="lt1"/>
+          </a:fontRef>
+        </p:style>
+        <p:txBody>
+          <a:bodyPr rtlCol="0" anchor="ctr"/>
+          <a:lstStyle/>
+          <a:p>
+            <a:pPr algn="ctr"/>
+          </a:p>
+        </p:txBody>
+      </p:sp>
+      <p:sp>
+        <p:nvSpPr>
+          <p:cNvPr id="84" name="TextBox 83"/>
+          <p:cNvSpPr txBox="1"/>
+          <p:nvPr/>
+        </p:nvSpPr>
+        <p:spPr>
+          <a:xfrm>
+            <a:off x="8299704" y="4334256"/>
+            <a:ext cx="310896" cy="310896"/>
+          </a:xfrm>
+          <a:prstGeom prst="rect">
+            <a:avLst/>
+          </a:prstGeom>
+          <a:noFill/>
+        </p:spPr>
+        <p:txBody>
+          <a:bodyPr wrap="square" anchor="ctr">
+            <a:spAutoFit/>
+          </a:bodyPr>
+          <a:lstStyle/>
+          <a:p>
+            <a:pPr algn="ctr"/>
+            <a:r>
+              <a:rPr sz="950" b="1">
+                <a:solidFill>
+                  <a:srgbClr val="FFFFFF"/>
+                </a:solidFill>
+                <a:latin typeface="微软雅黑"/>
+              </a:rPr>
+              <a:t>4</a:t>
+            </a:r>
+          </a:p>
+        </p:txBody>
+      </p:sp>
+      <p:sp>
+        <p:nvSpPr>
+          <p:cNvPr id="85" name="TextBox 84"/>
+          <p:cNvSpPr txBox="1"/>
+          <p:nvPr/>
+        </p:nvSpPr>
+        <p:spPr>
+          <a:xfrm>
+            <a:off x="8683752" y="4270248"/>
+            <a:ext cx="3048000" cy="237744"/>
+          </a:xfrm>
+          <a:prstGeom prst="rect">
+            <a:avLst/>
+          </a:prstGeom>
+          <a:noFill/>
+        </p:spPr>
+        <p:txBody>
+          <a:bodyPr wrap="square" anchor="ctr">
+            <a:spAutoFit/>
+          </a:bodyPr>
+          <a:lstStyle/>
+          <a:p>
+            <a:pPr algn="l"/>
+            <a:r>
+              <a:rPr sz="1050" b="1">
+                <a:solidFill>
+                  <a:srgbClr val="2D3748"/>
+                </a:solidFill>
+                <a:latin typeface="微软雅黑"/>
+              </a:rPr>
+              <a:t>论文/专利材料</a:t>
+            </a:r>
+          </a:p>
+        </p:txBody>
+      </p:sp>
+      <p:sp>
+        <p:nvSpPr>
+          <p:cNvPr id="86" name="TextBox 85"/>
+          <p:cNvSpPr txBox="1"/>
+          <p:nvPr/>
+        </p:nvSpPr>
+        <p:spPr>
+          <a:xfrm>
+            <a:off x="8683752" y="4517136"/>
+            <a:ext cx="3048000" cy="292608"/>
+          </a:xfrm>
+          <a:prstGeom prst="rect">
+            <a:avLst/>
+          </a:prstGeom>
+          <a:noFill/>
+        </p:spPr>
+        <p:txBody>
+          <a:bodyPr wrap="square" anchor="ctr">
+            <a:spAutoFit/>
+          </a:bodyPr>
+          <a:lstStyle/>
+          <a:p>
+            <a:pPr algn="l"/>
+            <a:r>
+              <a:rPr sz="830" b="0">
+                <a:solidFill>
+                  <a:srgbClr val="595959"/>
+                </a:solidFill>
+                <a:latin typeface="微软雅黑"/>
+              </a:rPr>
+              <a:t>时间窗常量 + 运行时特化 + 裁剪 JIT 的体系化总结</a:t>
+            </a:r>
+          </a:p>
+        </p:txBody>
+      </p:sp>
+      <p:sp>
+        <p:nvSpPr>
+          <p:cNvPr id="87" name="TextBox 86"/>
+          <p:cNvSpPr txBox="1"/>
+          <p:nvPr/>
+        </p:nvSpPr>
+        <p:spPr>
+          <a:xfrm>
+            <a:off x="320040" y="5367528"/>
+            <a:ext cx="11567160" cy="228600"/>
+          </a:xfrm>
+          <a:prstGeom prst="rect">
+            <a:avLst/>
+          </a:prstGeom>
+          <a:noFill/>
+        </p:spPr>
+        <p:txBody>
+          <a:bodyPr wrap="square" anchor="t">
+            <a:spAutoFit/>
+          </a:bodyPr>
+          <a:lstStyle/>
+          <a:p>
+            <a:pPr algn="l"/>
+            <a:r>
+              <a:rPr sz="1250" b="1">
+                <a:solidFill>
+                  <a:srgbClr val="2D3748"/>
+                </a:solidFill>
+                <a:latin typeface="微软雅黑"/>
+              </a:rPr>
+              <a:t>▎阶段性交付物</a:t>
+            </a:r>
+          </a:p>
+        </p:txBody>
+      </p:sp>
+      <p:sp>
+        <p:nvSpPr>
+          <p:cNvPr id="88" name="Rectangle 87"/>
+          <p:cNvSpPr/>
+          <p:nvPr/>
+        </p:nvSpPr>
+        <p:spPr>
+          <a:xfrm>
+            <a:off x="320040" y="5623560"/>
+            <a:ext cx="2788920" cy="658368"/>
+          </a:xfrm>
+          <a:prstGeom prst="rect">
+            <a:avLst/>
+          </a:prstGeom>
+          <a:solidFill>
+            <a:srgbClr val="F5F7FA"/>
+          </a:solidFill>
+          <a:ln w="6350">
+            <a:solidFill>
+              <a:srgbClr val="D9DEE6"/>
+            </a:solidFill>
+          </a:ln>
+          <a:effectLst/>
+        </p:spPr>
+        <p:style>
+          <a:lnRef idx="1">
+            <a:schemeClr val="accent1"/>
+          </a:lnRef>
+          <a:fillRef idx="3">
+            <a:schemeClr val="accent1"/>
+          </a:fillRef>
+          <a:effectRef idx="2">
+            <a:schemeClr val="accent1"/>
+          </a:effectRef>
+          <a:fontRef idx="minor">
+            <a:schemeClr val="lt1"/>
+          </a:fontRef>
+        </p:style>
+        <p:txBody>
+          <a:bodyPr rtlCol="0" anchor="ctr"/>
+          <a:lstStyle/>
+          <a:p>
+            <a:pPr algn="ctr"/>
+          </a:p>
+        </p:txBody>
+      </p:sp>
+      <p:sp>
+        <p:nvSpPr>
+          <p:cNvPr id="89" name="Rectangle 88"/>
+          <p:cNvSpPr/>
+          <p:nvPr/>
+        </p:nvSpPr>
+        <p:spPr>
+          <a:xfrm>
+            <a:off x="320040" y="5623560"/>
+            <a:ext cx="54864" cy="658368"/>
+          </a:xfrm>
+          <a:prstGeom prst="rect">
+            <a:avLst/>
+          </a:prstGeom>
+          <a:solidFill>
+            <a:srgbClr val="2C5282"/>
+          </a:solidFill>
+          <a:ln>
+            <a:noFill/>
+          </a:ln>
+          <a:effectLst/>
+        </p:spPr>
+        <p:style>
+          <a:lnRef idx="1">
+            <a:schemeClr val="accent1"/>
+          </a:lnRef>
+          <a:fillRef idx="3">
+            <a:schemeClr val="accent1"/>
+          </a:fillRef>
+          <a:effectRef idx="2">
+            <a:schemeClr val="accent1"/>
+          </a:effectRef>
+          <a:fontRef idx="minor">
+            <a:schemeClr val="lt1"/>
+          </a:fontRef>
+        </p:style>
+        <p:txBody>
+          <a:bodyPr rtlCol="0" anchor="ctr"/>
+          <a:lstStyle/>
+          <a:p>
+            <a:pPr algn="ctr"/>
+          </a:p>
+        </p:txBody>
+      </p:sp>
+      <p:sp>
+        <p:nvSpPr>
+          <p:cNvPr id="90" name="TextBox 89"/>
+          <p:cNvSpPr txBox="1"/>
+          <p:nvPr/>
+        </p:nvSpPr>
+        <p:spPr>
+          <a:xfrm>
+            <a:off x="484632" y="5678424"/>
+            <a:ext cx="2514600" cy="256032"/>
+          </a:xfrm>
+          <a:prstGeom prst="rect">
+            <a:avLst/>
+          </a:prstGeom>
+          <a:noFill/>
+        </p:spPr>
+        <p:txBody>
+          <a:bodyPr wrap="square" anchor="ctr">
+            <a:spAutoFit/>
+          </a:bodyPr>
+          <a:lstStyle/>
+          <a:p>
+            <a:pPr algn="l"/>
+            <a:r>
+              <a:rPr sz="1050" b="1">
+                <a:solidFill>
+                  <a:srgbClr val="2D3748"/>
+                </a:solidFill>
+                <a:latin typeface="微软雅黑"/>
+              </a:rPr>
+              <a:t>真机验证报告</a:t>
+            </a:r>
+          </a:p>
+        </p:txBody>
+      </p:sp>
+      <p:sp>
+        <p:nvSpPr>
+          <p:cNvPr id="91" name="TextBox 90"/>
+          <p:cNvSpPr txBox="1"/>
+          <p:nvPr/>
+        </p:nvSpPr>
+        <p:spPr>
+          <a:xfrm>
+            <a:off x="484632" y="5952744"/>
+            <a:ext cx="2514600" cy="256032"/>
+          </a:xfrm>
+          <a:prstGeom prst="rect">
+            <a:avLst/>
+          </a:prstGeom>
+          <a:noFill/>
+        </p:spPr>
+        <p:txBody>
+          <a:bodyPr wrap="square" anchor="ctr">
+            <a:spAutoFit/>
+          </a:bodyPr>
+          <a:lstStyle/>
+          <a:p>
+            <a:pPr algn="l"/>
+            <a:r>
+              <a:rPr sz="850" b="0">
+                <a:solidFill>
+                  <a:srgbClr val="595959"/>
+                </a:solidFill>
+                <a:latin typeface="微软雅黑"/>
+              </a:rPr>
+              <a:t>SRE 多核 / 裸核 / fallback</a:t>
+            </a:r>
+          </a:p>
+        </p:txBody>
+      </p:sp>
+      <p:sp>
+        <p:nvSpPr>
+          <p:cNvPr id="92" name="Rectangle 91"/>
+          <p:cNvSpPr/>
+          <p:nvPr/>
+        </p:nvSpPr>
+        <p:spPr>
+          <a:xfrm>
+            <a:off x="3246120" y="5623560"/>
+            <a:ext cx="2788920" cy="658368"/>
+          </a:xfrm>
+          <a:prstGeom prst="rect">
+            <a:avLst/>
+          </a:prstGeom>
+          <a:solidFill>
+            <a:srgbClr val="F5F7FA"/>
+          </a:solidFill>
+          <a:ln w="6350">
+            <a:solidFill>
+              <a:srgbClr val="D9DEE6"/>
+            </a:solidFill>
+          </a:ln>
+          <a:effectLst/>
+        </p:spPr>
+        <p:style>
+          <a:lnRef idx="1">
+            <a:schemeClr val="accent1"/>
+          </a:lnRef>
+          <a:fillRef idx="3">
+            <a:schemeClr val="accent1"/>
+          </a:fillRef>
+          <a:effectRef idx="2">
+            <a:schemeClr val="accent1"/>
+          </a:effectRef>
+          <a:fontRef idx="minor">
+            <a:schemeClr val="lt1"/>
+          </a:fontRef>
+        </p:style>
+        <p:txBody>
+          <a:bodyPr rtlCol="0" anchor="ctr"/>
+          <a:lstStyle/>
+          <a:p>
+            <a:pPr algn="ctr"/>
+          </a:p>
+        </p:txBody>
+      </p:sp>
+      <p:sp>
+        <p:nvSpPr>
+          <p:cNvPr id="93" name="Rectangle 92"/>
+          <p:cNvSpPr/>
+          <p:nvPr/>
+        </p:nvSpPr>
+        <p:spPr>
+          <a:xfrm>
+            <a:off x="3246120" y="5623560"/>
+            <a:ext cx="54864" cy="658368"/>
+          </a:xfrm>
+          <a:prstGeom prst="rect">
+            <a:avLst/>
+          </a:prstGeom>
+          <a:solidFill>
+            <a:srgbClr val="2C5282"/>
+          </a:solidFill>
+          <a:ln>
+            <a:noFill/>
+          </a:ln>
+          <a:effectLst/>
+        </p:spPr>
+        <p:style>
+          <a:lnRef idx="1">
+            <a:schemeClr val="accent1"/>
+          </a:lnRef>
+          <a:fillRef idx="3">
+            <a:schemeClr val="accent1"/>
+          </a:fillRef>
+          <a:effectRef idx="2">
+            <a:schemeClr val="accent1"/>
+          </a:effectRef>
+          <a:fontRef idx="minor">
+            <a:schemeClr val="lt1"/>
+          </a:fontRef>
+        </p:style>
+        <p:txBody>
+          <a:bodyPr rtlCol="0" anchor="ctr"/>
+          <a:lstStyle/>
+          <a:p>
+            <a:pPr algn="ctr"/>
+          </a:p>
+        </p:txBody>
+      </p:sp>
+      <p:sp>
+        <p:nvSpPr>
+          <p:cNvPr id="94" name="TextBox 93"/>
+          <p:cNvSpPr txBox="1"/>
+          <p:nvPr/>
+        </p:nvSpPr>
+        <p:spPr>
+          <a:xfrm>
+            <a:off x="3410712" y="5678424"/>
+            <a:ext cx="2514600" cy="256032"/>
+          </a:xfrm>
+          <a:prstGeom prst="rect">
+            <a:avLst/>
+          </a:prstGeom>
+          <a:noFill/>
+        </p:spPr>
+        <p:txBody>
+          <a:bodyPr wrap="square" anchor="ctr">
+            <a:spAutoFit/>
+          </a:bodyPr>
+          <a:lstStyle/>
+          <a:p>
+            <a:pPr algn="l"/>
+            <a:r>
+              <a:rPr sz="1050" b="1">
+                <a:solidFill>
+                  <a:srgbClr val="2D3748"/>
+                </a:solidFill>
+                <a:latin typeface="微软雅黑"/>
+              </a:rPr>
+              <a:t>性能收益表</a:t>
+            </a:r>
+          </a:p>
+        </p:txBody>
+      </p:sp>
+      <p:sp>
+        <p:nvSpPr>
+          <p:cNvPr id="95" name="TextBox 94"/>
+          <p:cNvSpPr txBox="1"/>
+          <p:nvPr/>
+        </p:nvSpPr>
+        <p:spPr>
+          <a:xfrm>
+            <a:off x="3410712" y="5952744"/>
+            <a:ext cx="2514600" cy="256032"/>
+          </a:xfrm>
+          <a:prstGeom prst="rect">
+            <a:avLst/>
+          </a:prstGeom>
+          <a:noFill/>
+        </p:spPr>
+        <p:txBody>
+          <a:bodyPr wrap="square" anchor="ctr">
+            <a:spAutoFit/>
+          </a:bodyPr>
+          <a:lstStyle/>
+          <a:p>
+            <a:pPr algn="l"/>
+            <a:r>
+              <a:rPr sz="850" b="0">
+                <a:solidFill>
+                  <a:srgbClr val="595959"/>
+                </a:solidFill>
+                <a:latin typeface="微软雅黑"/>
+              </a:rPr>
+              <a:t>命中率 / 耗时 / 加速比</a:t>
+            </a:r>
+          </a:p>
+        </p:txBody>
+      </p:sp>
+      <p:sp>
+        <p:nvSpPr>
+          <p:cNvPr id="96" name="Rectangle 95"/>
+          <p:cNvSpPr/>
+          <p:nvPr/>
+        </p:nvSpPr>
+        <p:spPr>
+          <a:xfrm>
+            <a:off x="6172200" y="5623560"/>
+            <a:ext cx="2788920" cy="658368"/>
+          </a:xfrm>
+          <a:prstGeom prst="rect">
+            <a:avLst/>
+          </a:prstGeom>
+          <a:solidFill>
+            <a:srgbClr val="F5F7FA"/>
+          </a:solidFill>
+          <a:ln w="6350">
+            <a:solidFill>
+              <a:srgbClr val="D9DEE6"/>
+            </a:solidFill>
+          </a:ln>
+          <a:effectLst/>
+        </p:spPr>
+        <p:style>
+          <a:lnRef idx="1">
+            <a:schemeClr val="accent1"/>
+          </a:lnRef>
+          <a:fillRef idx="3">
+            <a:schemeClr val="accent1"/>
+          </a:fillRef>
+          <a:effectRef idx="2">
+            <a:schemeClr val="accent1"/>
+          </a:effectRef>
+          <a:fontRef idx="minor">
+            <a:schemeClr val="lt1"/>
+          </a:fontRef>
+        </p:style>
+        <p:txBody>
+          <a:bodyPr rtlCol="0" anchor="ctr"/>
+          <a:lstStyle/>
+          <a:p>
+            <a:pPr algn="ctr"/>
+          </a:p>
+        </p:txBody>
+      </p:sp>
+      <p:sp>
+        <p:nvSpPr>
+          <p:cNvPr id="97" name="Rectangle 96"/>
+          <p:cNvSpPr/>
+          <p:nvPr/>
+        </p:nvSpPr>
+        <p:spPr>
+          <a:xfrm>
+            <a:off x="6172200" y="5623560"/>
+            <a:ext cx="54864" cy="658368"/>
+          </a:xfrm>
+          <a:prstGeom prst="rect">
+            <a:avLst/>
+          </a:prstGeom>
+          <a:solidFill>
+            <a:srgbClr val="2C5282"/>
+          </a:solidFill>
+          <a:ln>
+            <a:noFill/>
+          </a:ln>
+          <a:effectLst/>
+        </p:spPr>
+        <p:style>
+          <a:lnRef idx="1">
+            <a:schemeClr val="accent1"/>
+          </a:lnRef>
+          <a:fillRef idx="3">
+            <a:schemeClr val="accent1"/>
+          </a:fillRef>
+          <a:effectRef idx="2">
+            <a:schemeClr val="accent1"/>
+          </a:effectRef>
+          <a:fontRef idx="minor">
+            <a:schemeClr val="lt1"/>
+          </a:fontRef>
+        </p:style>
+        <p:txBody>
+          <a:bodyPr rtlCol="0" anchor="ctr"/>
+          <a:lstStyle/>
+          <a:p>
+            <a:pPr algn="ctr"/>
+          </a:p>
+        </p:txBody>
+      </p:sp>
+      <p:sp>
+        <p:nvSpPr>
+          <p:cNvPr id="98" name="TextBox 97"/>
+          <p:cNvSpPr txBox="1"/>
+          <p:nvPr/>
+        </p:nvSpPr>
+        <p:spPr>
+          <a:xfrm>
+            <a:off x="6336792" y="5678424"/>
+            <a:ext cx="2514600" cy="256032"/>
+          </a:xfrm>
+          <a:prstGeom prst="rect">
+            <a:avLst/>
+          </a:prstGeom>
+          <a:noFill/>
+        </p:spPr>
+        <p:txBody>
+          <a:bodyPr wrap="square" anchor="ctr">
+            <a:spAutoFit/>
+          </a:bodyPr>
+          <a:lstStyle/>
+          <a:p>
+            <a:pPr algn="l"/>
+            <a:r>
+              <a:rPr sz="1050" b="1">
+                <a:solidFill>
+                  <a:srgbClr val="2D3748"/>
+                </a:solidFill>
+                <a:latin typeface="微软雅黑"/>
+              </a:rPr>
+              <a:t>裁剪构建包</a:t>
+            </a:r>
+          </a:p>
+        </p:txBody>
+      </p:sp>
+      <p:sp>
+        <p:nvSpPr>
+          <p:cNvPr id="99" name="TextBox 98"/>
+          <p:cNvSpPr txBox="1"/>
+          <p:nvPr/>
+        </p:nvSpPr>
+        <p:spPr>
+          <a:xfrm>
+            <a:off x="6336792" y="5952744"/>
+            <a:ext cx="2514600" cy="256032"/>
+          </a:xfrm>
+          <a:prstGeom prst="rect">
+            <a:avLst/>
+          </a:prstGeom>
+          <a:noFill/>
+        </p:spPr>
+        <p:txBody>
+          <a:bodyPr wrap="square" anchor="ctr">
+            <a:spAutoFit/>
+          </a:bodyPr>
+          <a:lstStyle/>
+          <a:p>
+            <a:pPr algn="l"/>
+            <a:r>
+              <a:rPr sz="850" b="0">
+                <a:solidFill>
+                  <a:srgbClr val="595959"/>
+                </a:solidFill>
+                <a:latin typeface="微软雅黑"/>
+              </a:rPr>
+              <a:t>LLVMEJIT.a / 单 ejit.o</a:t>
+            </a:r>
+          </a:p>
+        </p:txBody>
+      </p:sp>
+      <p:sp>
+        <p:nvSpPr>
+          <p:cNvPr id="100" name="Rectangle 99"/>
+          <p:cNvSpPr/>
+          <p:nvPr/>
+        </p:nvSpPr>
+        <p:spPr>
+          <a:xfrm>
+            <a:off x="9098280" y="5623560"/>
+            <a:ext cx="2788920" cy="658368"/>
+          </a:xfrm>
+          <a:prstGeom prst="rect">
+            <a:avLst/>
+          </a:prstGeom>
+          <a:solidFill>
+            <a:srgbClr val="F5F7FA"/>
+          </a:solidFill>
+          <a:ln w="6350">
+            <a:solidFill>
+              <a:srgbClr val="D9DEE6"/>
+            </a:solidFill>
+          </a:ln>
+          <a:effectLst/>
+        </p:spPr>
+        <p:style>
+          <a:lnRef idx="1">
+            <a:schemeClr val="accent1"/>
+          </a:lnRef>
+          <a:fillRef idx="3">
+            <a:schemeClr val="accent1"/>
+          </a:fillRef>
+          <a:effectRef idx="2">
+            <a:schemeClr val="accent1"/>
+          </a:effectRef>
+          <a:fontRef idx="minor">
+            <a:schemeClr val="lt1"/>
+          </a:fontRef>
+        </p:style>
+        <p:txBody>
+          <a:bodyPr rtlCol="0" anchor="ctr"/>
+          <a:lstStyle/>
+          <a:p>
+            <a:pPr algn="ctr"/>
+          </a:p>
+        </p:txBody>
+      </p:sp>
+      <p:sp>
+        <p:nvSpPr>
+          <p:cNvPr id="101" name="Rectangle 100"/>
+          <p:cNvSpPr/>
+          <p:nvPr/>
+        </p:nvSpPr>
+        <p:spPr>
+          <a:xfrm>
+            <a:off x="9098280" y="5623560"/>
+            <a:ext cx="54864" cy="658368"/>
+          </a:xfrm>
+          <a:prstGeom prst="rect">
+            <a:avLst/>
+          </a:prstGeom>
+          <a:solidFill>
+            <a:srgbClr val="2C5282"/>
+          </a:solidFill>
+          <a:ln>
+            <a:noFill/>
+          </a:ln>
+          <a:effectLst/>
+        </p:spPr>
+        <p:style>
+          <a:lnRef idx="1">
+            <a:schemeClr val="accent1"/>
+          </a:lnRef>
+          <a:fillRef idx="3">
+            <a:schemeClr val="accent1"/>
+          </a:fillRef>
+          <a:effectRef idx="2">
+            <a:schemeClr val="accent1"/>
+          </a:effectRef>
+          <a:fontRef idx="minor">
+            <a:schemeClr val="lt1"/>
+          </a:fontRef>
+        </p:style>
+        <p:txBody>
+          <a:bodyPr rtlCol="0" anchor="ctr"/>
+          <a:lstStyle/>
+          <a:p>
+            <a:pPr algn="ctr"/>
+          </a:p>
+        </p:txBody>
+      </p:sp>
+      <p:sp>
+        <p:nvSpPr>
+          <p:cNvPr id="102" name="TextBox 101"/>
+          <p:cNvSpPr txBox="1"/>
+          <p:nvPr/>
+        </p:nvSpPr>
+        <p:spPr>
+          <a:xfrm>
+            <a:off x="9262872" y="5678424"/>
+            <a:ext cx="2514600" cy="256032"/>
+          </a:xfrm>
+          <a:prstGeom prst="rect">
+            <a:avLst/>
+          </a:prstGeom>
+          <a:noFill/>
+        </p:spPr>
+        <p:txBody>
+          <a:bodyPr wrap="square" anchor="ctr">
+            <a:spAutoFit/>
+          </a:bodyPr>
+          <a:lstStyle/>
+          <a:p>
+            <a:pPr algn="l"/>
+            <a:r>
+              <a:rPr sz="1050" b="1">
+                <a:solidFill>
+                  <a:srgbClr val="2D3748"/>
+                </a:solidFill>
+                <a:latin typeface="微软雅黑"/>
+              </a:rPr>
+              <a:t>可复现 Demo</a:t>
+            </a:r>
+          </a:p>
+        </p:txBody>
+      </p:sp>
+      <p:sp>
+        <p:nvSpPr>
+          <p:cNvPr id="103" name="TextBox 102"/>
+          <p:cNvSpPr txBox="1"/>
+          <p:nvPr/>
+        </p:nvSpPr>
+        <p:spPr>
+          <a:xfrm>
+            <a:off x="9262872" y="5952744"/>
+            <a:ext cx="2514600" cy="256032"/>
+          </a:xfrm>
+          <a:prstGeom prst="rect">
+            <a:avLst/>
+          </a:prstGeom>
+          <a:noFill/>
+        </p:spPr>
+        <p:txBody>
+          <a:bodyPr wrap="square" anchor="ctr">
+            <a:spAutoFit/>
+          </a:bodyPr>
+          <a:lstStyle/>
+          <a:p>
+            <a:pPr algn="l"/>
+            <a:r>
+              <a:rPr sz="850" b="0">
+                <a:solidFill>
+                  <a:srgbClr val="595959"/>
+                </a:solidFill>
+                <a:latin typeface="微软雅黑"/>
+              </a:rPr>
+              <a:t>脚本 + 测试 + 文档</a:t>
+            </a:r>
+          </a:p>
+        </p:txBody>
+      </p:sp>
+    </p:spTree>
+  </p:cSld>
+  <p:clrMapOvr>
+    <a:masterClrMapping/>
+  </p:clrMapOvr>
+</p:sld>
+</file>
+
+<file path=ppt/slides/slide4.xml><?xml version="1.0" encoding="utf-8"?>
 <p:sld xmlns:a="http://schemas.openxmlformats.org/drawingml/2006/main" xmlns:p="http://schemas.openxmlformats.org/presentationml/2006/main" xmlns:r="http://schemas.openxmlformats.org/officeDocument/2006/relationships">
   <p:cSld>
     <p:spTree>

</xml_diff>